<commit_message>
Actualize course information in first lecture, finalize abstract data structures and sorting algorithms presentation. TODO sixth lecture
</commit_message>
<xml_diff>
--- a/MyOwnPresentations/Abstract_Datatypes_V.pptx
+++ b/MyOwnPresentations/Abstract_Datatypes_V.pptx
@@ -32,21 +32,21 @@
     <p:sldId id="279" r:id="rId26"/>
     <p:sldId id="280" r:id="rId27"/>
     <p:sldId id="281" r:id="rId28"/>
-    <p:sldId id="291" r:id="rId29"/>
-    <p:sldId id="292" r:id="rId30"/>
-    <p:sldId id="293" r:id="rId31"/>
-    <p:sldId id="294" r:id="rId32"/>
-    <p:sldId id="295" r:id="rId33"/>
-    <p:sldId id="296" r:id="rId34"/>
-    <p:sldId id="297" r:id="rId35"/>
-    <p:sldId id="298" r:id="rId36"/>
-    <p:sldId id="299" r:id="rId37"/>
-    <p:sldId id="300" r:id="rId38"/>
-    <p:sldId id="301" r:id="rId39"/>
-    <p:sldId id="302" r:id="rId40"/>
-    <p:sldId id="303" r:id="rId41"/>
-    <p:sldId id="304" r:id="rId42"/>
-    <p:sldId id="305" r:id="rId43"/>
+    <p:sldId id="334" r:id="rId29"/>
+    <p:sldId id="291" r:id="rId30"/>
+    <p:sldId id="292" r:id="rId31"/>
+    <p:sldId id="293" r:id="rId32"/>
+    <p:sldId id="294" r:id="rId33"/>
+    <p:sldId id="295" r:id="rId34"/>
+    <p:sldId id="296" r:id="rId35"/>
+    <p:sldId id="297" r:id="rId36"/>
+    <p:sldId id="298" r:id="rId37"/>
+    <p:sldId id="299" r:id="rId38"/>
+    <p:sldId id="300" r:id="rId39"/>
+    <p:sldId id="301" r:id="rId40"/>
+    <p:sldId id="302" r:id="rId41"/>
+    <p:sldId id="303" r:id="rId42"/>
+    <p:sldId id="304" r:id="rId43"/>
     <p:sldId id="306" r:id="rId44"/>
     <p:sldId id="307" r:id="rId45"/>
     <p:sldId id="308" r:id="rId46"/>
@@ -57,7 +57,20 @@
     <p:sldId id="313" r:id="rId51"/>
     <p:sldId id="314" r:id="rId52"/>
     <p:sldId id="315" r:id="rId53"/>
-    <p:sldId id="316" r:id="rId54"/>
+    <p:sldId id="317" r:id="rId54"/>
+    <p:sldId id="316" r:id="rId55"/>
+    <p:sldId id="318" r:id="rId56"/>
+    <p:sldId id="319" r:id="rId57"/>
+    <p:sldId id="321" r:id="rId58"/>
+    <p:sldId id="322" r:id="rId59"/>
+    <p:sldId id="323" r:id="rId60"/>
+    <p:sldId id="324" r:id="rId61"/>
+    <p:sldId id="325" r:id="rId62"/>
+    <p:sldId id="326" r:id="rId63"/>
+    <p:sldId id="327" r:id="rId64"/>
+    <p:sldId id="328" r:id="rId65"/>
+    <p:sldId id="330" r:id="rId66"/>
+    <p:sldId id="333" r:id="rId67"/>
   </p:sldIdLst>
   <p:sldSz cx="12192000" cy="6858000"/>
   <p:notesSz cx="6858000" cy="9144000"/>
@@ -156,6 +169,11 @@
       </a:defRPr>
     </a:lvl9pPr>
   </p:defaultTextStyle>
+  <p:extLst>
+    <p:ext uri="{EFAFB233-063F-42B5-8137-9DF3F51BA10A}">
+      <p15:sldGuideLst xmlns:p15="http://schemas.microsoft.com/office/powerpoint/2012/main"/>
+    </p:ext>
+  </p:extLst>
 </p:presentation>
 </file>
 
@@ -3281,7 +3299,7 @@
         <a:p>
           <a:r>
             <a:rPr lang="en-US" dirty="0"/>
-            <a:t>Compound data types</a:t>
+            <a:t>Composite  data types</a:t>
           </a:r>
         </a:p>
       </dgm:t>
@@ -3425,7 +3443,7 @@
         <a:p>
           <a:r>
             <a:rPr lang="en-US" dirty="0"/>
-            <a:t>Compound Building blocks</a:t>
+            <a:t>Composite Building blocks</a:t>
           </a:r>
         </a:p>
       </dgm:t>
@@ -4396,8 +4414,8 @@
       </dsp:nvSpPr>
       <dsp:spPr>
         <a:xfrm>
-          <a:off x="908818" y="1178"/>
-          <a:ext cx="2485132" cy="1242566"/>
+          <a:off x="588776" y="4352"/>
+          <a:ext cx="2936890" cy="1468445"/>
         </a:xfrm>
         <a:prstGeom prst="roundRect">
           <a:avLst>
@@ -4441,12 +4459,12 @@
         </a:fontRef>
       </dsp:style>
       <dsp:txBody>
-        <a:bodyPr spcFirstLastPara="0" vert="horz" wrap="square" lIns="51435" tIns="34290" rIns="51435" bIns="34290" numCol="1" spcCol="1270" anchor="ctr" anchorCtr="0">
+        <a:bodyPr spcFirstLastPara="0" vert="horz" wrap="square" lIns="60960" tIns="40640" rIns="60960" bIns="40640" numCol="1" spcCol="1270" anchor="ctr" anchorCtr="0">
           <a:noAutofit/>
         </a:bodyPr>
         <a:lstStyle/>
         <a:p>
-          <a:pPr marL="0" lvl="0" indent="0" algn="ctr" defTabSz="1200150">
+          <a:pPr marL="0" lvl="0" indent="0" algn="ctr" defTabSz="1422400">
             <a:lnSpc>
               <a:spcPct val="90000"/>
             </a:lnSpc>
@@ -4459,14 +4477,14 @@
             <a:buNone/>
           </a:pPr>
           <a:r>
-            <a:rPr lang="en-US" sz="2700" kern="1200" dirty="0"/>
+            <a:rPr lang="en-US" sz="3200" kern="1200" dirty="0"/>
             <a:t>Simple Building blocks</a:t>
           </a:r>
         </a:p>
       </dsp:txBody>
       <dsp:txXfrm>
-        <a:off x="945212" y="37572"/>
-        <a:ext cx="2412344" cy="1169778"/>
+        <a:off x="631785" y="47361"/>
+        <a:ext cx="2850872" cy="1382427"/>
       </dsp:txXfrm>
     </dsp:sp>
     <dsp:sp modelId="{CB4ADF5D-236A-42AF-82E5-026F6BFD0FB8}">
@@ -4476,8 +4494,8 @@
       </dsp:nvSpPr>
       <dsp:spPr>
         <a:xfrm>
-          <a:off x="1157332" y="1243744"/>
-          <a:ext cx="248513" cy="931924"/>
+          <a:off x="882465" y="1472797"/>
+          <a:ext cx="293689" cy="1101333"/>
         </a:xfrm>
         <a:custGeom>
           <a:avLst/>
@@ -4491,10 +4509,10 @@
                 <a:pt x="0" y="0"/>
               </a:moveTo>
               <a:lnTo>
-                <a:pt x="0" y="931924"/>
+                <a:pt x="0" y="1101333"/>
               </a:lnTo>
               <a:lnTo>
-                <a:pt x="248513" y="931924"/>
+                <a:pt x="293689" y="1101333"/>
               </a:lnTo>
             </a:path>
           </a:pathLst>
@@ -4535,8 +4553,8 @@
       </dsp:nvSpPr>
       <dsp:spPr>
         <a:xfrm>
-          <a:off x="1405845" y="1554385"/>
-          <a:ext cx="1988105" cy="1242566"/>
+          <a:off x="1176154" y="1839908"/>
+          <a:ext cx="2349512" cy="1468445"/>
         </a:xfrm>
         <a:prstGeom prst="roundRect">
           <a:avLst>
@@ -4579,12 +4597,12 @@
         <a:fontRef idx="minor"/>
       </dsp:style>
       <dsp:txBody>
-        <a:bodyPr spcFirstLastPara="0" vert="horz" wrap="square" lIns="55245" tIns="36830" rIns="55245" bIns="36830" numCol="1" spcCol="1270" anchor="ctr" anchorCtr="0">
+        <a:bodyPr spcFirstLastPara="0" vert="horz" wrap="square" lIns="66675" tIns="44450" rIns="66675" bIns="44450" numCol="1" spcCol="1270" anchor="ctr" anchorCtr="0">
           <a:noAutofit/>
         </a:bodyPr>
         <a:lstStyle/>
         <a:p>
-          <a:pPr marL="0" lvl="0" indent="0" algn="ctr" defTabSz="1289050">
+          <a:pPr marL="0" lvl="0" indent="0" algn="ctr" defTabSz="1555750">
             <a:lnSpc>
               <a:spcPct val="90000"/>
             </a:lnSpc>
@@ -4597,14 +4615,14 @@
             <a:buNone/>
           </a:pPr>
           <a:r>
-            <a:rPr lang="en-US" sz="2900" kern="1200" dirty="0"/>
+            <a:rPr lang="en-US" sz="3500" kern="1200" dirty="0"/>
             <a:t>Primitive data types </a:t>
           </a:r>
         </a:p>
       </dsp:txBody>
       <dsp:txXfrm>
-        <a:off x="1442239" y="1590779"/>
-        <a:ext cx="1915317" cy="1169778"/>
+        <a:off x="1219163" y="1882917"/>
+        <a:ext cx="2263494" cy="1382427"/>
       </dsp:txXfrm>
     </dsp:sp>
     <dsp:sp modelId="{0A1639EA-4FAA-4160-A27E-C19A7B26BB6F}">
@@ -4614,8 +4632,8 @@
       </dsp:nvSpPr>
       <dsp:spPr>
         <a:xfrm>
-          <a:off x="1157332" y="1243744"/>
-          <a:ext cx="248513" cy="2485132"/>
+          <a:off x="882465" y="1472797"/>
+          <a:ext cx="293689" cy="2936890"/>
         </a:xfrm>
         <a:custGeom>
           <a:avLst/>
@@ -4629,10 +4647,10 @@
                 <a:pt x="0" y="0"/>
               </a:moveTo>
               <a:lnTo>
-                <a:pt x="0" y="2485132"/>
+                <a:pt x="0" y="2936890"/>
               </a:lnTo>
               <a:lnTo>
-                <a:pt x="248513" y="2485132"/>
+                <a:pt x="293689" y="2936890"/>
               </a:lnTo>
             </a:path>
           </a:pathLst>
@@ -4673,8 +4691,8 @@
       </dsp:nvSpPr>
       <dsp:spPr>
         <a:xfrm>
-          <a:off x="1405845" y="3107593"/>
-          <a:ext cx="1988105" cy="1242566"/>
+          <a:off x="1176154" y="3675465"/>
+          <a:ext cx="2349512" cy="1468445"/>
         </a:xfrm>
         <a:prstGeom prst="roundRect">
           <a:avLst>
@@ -4717,12 +4735,12 @@
         <a:fontRef idx="minor"/>
       </dsp:style>
       <dsp:txBody>
-        <a:bodyPr spcFirstLastPara="0" vert="horz" wrap="square" lIns="55245" tIns="36830" rIns="55245" bIns="36830" numCol="1" spcCol="1270" anchor="ctr" anchorCtr="0">
+        <a:bodyPr spcFirstLastPara="0" vert="horz" wrap="square" lIns="66675" tIns="44450" rIns="66675" bIns="44450" numCol="1" spcCol="1270" anchor="ctr" anchorCtr="0">
           <a:noAutofit/>
         </a:bodyPr>
         <a:lstStyle/>
         <a:p>
-          <a:pPr marL="0" lvl="0" indent="0" algn="ctr" defTabSz="1289050">
+          <a:pPr marL="0" lvl="0" indent="0" algn="ctr" defTabSz="1555750">
             <a:lnSpc>
               <a:spcPct val="90000"/>
             </a:lnSpc>
@@ -4735,14 +4753,14 @@
             <a:buNone/>
           </a:pPr>
           <a:r>
-            <a:rPr lang="en-US" sz="2900" kern="1200" dirty="0"/>
-            <a:t>Compound data types</a:t>
+            <a:rPr lang="en-US" sz="3500" kern="1200" dirty="0"/>
+            <a:t>Composite  data types</a:t>
           </a:r>
         </a:p>
       </dsp:txBody>
       <dsp:txXfrm>
-        <a:off x="1442239" y="3143987"/>
-        <a:ext cx="1915317" cy="1169778"/>
+        <a:off x="1219163" y="3718474"/>
+        <a:ext cx="2263494" cy="1382427"/>
       </dsp:txXfrm>
     </dsp:sp>
     <dsp:sp modelId="{7D49BFD5-9B26-47EF-8BBA-E8902E5824F8}">
@@ -4752,8 +4770,8 @@
       </dsp:nvSpPr>
       <dsp:spPr>
         <a:xfrm>
-          <a:off x="4015233" y="1178"/>
-          <a:ext cx="2485132" cy="1242566"/>
+          <a:off x="4259889" y="4352"/>
+          <a:ext cx="2936890" cy="1468445"/>
         </a:xfrm>
         <a:prstGeom prst="roundRect">
           <a:avLst>
@@ -4797,12 +4815,12 @@
         </a:fontRef>
       </dsp:style>
       <dsp:txBody>
-        <a:bodyPr spcFirstLastPara="0" vert="horz" wrap="square" lIns="51435" tIns="34290" rIns="51435" bIns="34290" numCol="1" spcCol="1270" anchor="ctr" anchorCtr="0">
+        <a:bodyPr spcFirstLastPara="0" vert="horz" wrap="square" lIns="60960" tIns="40640" rIns="60960" bIns="40640" numCol="1" spcCol="1270" anchor="ctr" anchorCtr="0">
           <a:noAutofit/>
         </a:bodyPr>
         <a:lstStyle/>
         <a:p>
-          <a:pPr marL="0" lvl="0" indent="0" algn="ctr" defTabSz="1200150">
+          <a:pPr marL="0" lvl="0" indent="0" algn="ctr" defTabSz="1422400">
             <a:lnSpc>
               <a:spcPct val="90000"/>
             </a:lnSpc>
@@ -4815,14 +4833,14 @@
             <a:buNone/>
           </a:pPr>
           <a:r>
-            <a:rPr lang="en-US" sz="2700" kern="1200" dirty="0"/>
+            <a:rPr lang="en-US" sz="3200" kern="1200" dirty="0"/>
             <a:t>Material type</a:t>
           </a:r>
         </a:p>
       </dsp:txBody>
       <dsp:txXfrm>
-        <a:off x="4051627" y="37572"/>
-        <a:ext cx="2412344" cy="1169778"/>
+        <a:off x="4302898" y="47361"/>
+        <a:ext cx="2850872" cy="1382427"/>
       </dsp:txXfrm>
     </dsp:sp>
     <dsp:sp modelId="{28F64A9C-3648-471C-8BF8-D21E28BB21CA}">
@@ -4832,8 +4850,8 @@
       </dsp:nvSpPr>
       <dsp:spPr>
         <a:xfrm>
-          <a:off x="4263747" y="1243744"/>
-          <a:ext cx="248513" cy="931924"/>
+          <a:off x="4553578" y="1472797"/>
+          <a:ext cx="293689" cy="1101333"/>
         </a:xfrm>
         <a:custGeom>
           <a:avLst/>
@@ -4847,10 +4865,10 @@
                 <a:pt x="0" y="0"/>
               </a:moveTo>
               <a:lnTo>
-                <a:pt x="0" y="931924"/>
+                <a:pt x="0" y="1101333"/>
               </a:lnTo>
               <a:lnTo>
-                <a:pt x="248513" y="931924"/>
+                <a:pt x="293689" y="1101333"/>
               </a:lnTo>
             </a:path>
           </a:pathLst>
@@ -4891,8 +4909,8 @@
       </dsp:nvSpPr>
       <dsp:spPr>
         <a:xfrm>
-          <a:off x="4512260" y="1554385"/>
-          <a:ext cx="1988105" cy="1242566"/>
+          <a:off x="4847267" y="1839908"/>
+          <a:ext cx="2349512" cy="1468445"/>
         </a:xfrm>
         <a:prstGeom prst="roundRect">
           <a:avLst>
@@ -4935,12 +4953,12 @@
         <a:fontRef idx="minor"/>
       </dsp:style>
       <dsp:txBody>
-        <a:bodyPr spcFirstLastPara="0" vert="horz" wrap="square" lIns="55245" tIns="36830" rIns="55245" bIns="36830" numCol="1" spcCol="1270" anchor="ctr" anchorCtr="0">
+        <a:bodyPr spcFirstLastPara="0" vert="horz" wrap="square" lIns="66675" tIns="44450" rIns="66675" bIns="44450" numCol="1" spcCol="1270" anchor="ctr" anchorCtr="0">
           <a:noAutofit/>
         </a:bodyPr>
         <a:lstStyle/>
         <a:p>
-          <a:pPr marL="0" lvl="0" indent="0" algn="ctr" defTabSz="1289050">
+          <a:pPr marL="0" lvl="0" indent="0" algn="ctr" defTabSz="1555750">
             <a:lnSpc>
               <a:spcPct val="90000"/>
             </a:lnSpc>
@@ -4953,14 +4971,14 @@
             <a:buNone/>
           </a:pPr>
           <a:r>
-            <a:rPr lang="en-US" sz="2900" kern="1200" dirty="0"/>
+            <a:rPr lang="en-US" sz="3500" kern="1200" dirty="0"/>
             <a:t>Fixed / rigid</a:t>
           </a:r>
         </a:p>
       </dsp:txBody>
       <dsp:txXfrm>
-        <a:off x="4548654" y="1590779"/>
-        <a:ext cx="1915317" cy="1169778"/>
+        <a:off x="4890276" y="1882917"/>
+        <a:ext cx="2263494" cy="1382427"/>
       </dsp:txXfrm>
     </dsp:sp>
     <dsp:sp modelId="{75B89CA9-7ECA-4E10-AF1C-B78BEF2AE3A8}">
@@ -4970,8 +4988,8 @@
       </dsp:nvSpPr>
       <dsp:spPr>
         <a:xfrm>
-          <a:off x="4263747" y="1243744"/>
-          <a:ext cx="248513" cy="2485132"/>
+          <a:off x="4553578" y="1472797"/>
+          <a:ext cx="293689" cy="2936890"/>
         </a:xfrm>
         <a:custGeom>
           <a:avLst/>
@@ -4985,10 +5003,10 @@
                 <a:pt x="0" y="0"/>
               </a:moveTo>
               <a:lnTo>
-                <a:pt x="0" y="2485132"/>
+                <a:pt x="0" y="2936890"/>
               </a:lnTo>
               <a:lnTo>
-                <a:pt x="248513" y="2485132"/>
+                <a:pt x="293689" y="2936890"/>
               </a:lnTo>
             </a:path>
           </a:pathLst>
@@ -5029,8 +5047,8 @@
       </dsp:nvSpPr>
       <dsp:spPr>
         <a:xfrm>
-          <a:off x="4512260" y="3107593"/>
-          <a:ext cx="1988105" cy="1242566"/>
+          <a:off x="4847267" y="3675465"/>
+          <a:ext cx="2349512" cy="1468445"/>
         </a:xfrm>
         <a:prstGeom prst="roundRect">
           <a:avLst>
@@ -5073,12 +5091,12 @@
         <a:fontRef idx="minor"/>
       </dsp:style>
       <dsp:txBody>
-        <a:bodyPr spcFirstLastPara="0" vert="horz" wrap="square" lIns="55245" tIns="36830" rIns="55245" bIns="36830" numCol="1" spcCol="1270" anchor="ctr" anchorCtr="0">
+        <a:bodyPr spcFirstLastPara="0" vert="horz" wrap="square" lIns="66675" tIns="44450" rIns="66675" bIns="44450" numCol="1" spcCol="1270" anchor="ctr" anchorCtr="0">
           <a:noAutofit/>
         </a:bodyPr>
         <a:lstStyle/>
         <a:p>
-          <a:pPr marL="0" lvl="0" indent="0" algn="ctr" defTabSz="1289050">
+          <a:pPr marL="0" lvl="0" indent="0" algn="ctr" defTabSz="1555750">
             <a:lnSpc>
               <a:spcPct val="90000"/>
             </a:lnSpc>
@@ -5091,14 +5109,14 @@
             <a:buNone/>
           </a:pPr>
           <a:r>
-            <a:rPr lang="en-US" sz="2900" kern="1200" dirty="0"/>
+            <a:rPr lang="en-US" sz="3500" kern="1200" dirty="0"/>
             <a:t>Flexible / Dynamic</a:t>
           </a:r>
         </a:p>
       </dsp:txBody>
       <dsp:txXfrm>
-        <a:off x="4548654" y="3143987"/>
-        <a:ext cx="1915317" cy="1169778"/>
+        <a:off x="4890276" y="3718474"/>
+        <a:ext cx="2263494" cy="1382427"/>
       </dsp:txXfrm>
     </dsp:sp>
     <dsp:sp modelId="{C3B9206C-0A7B-4529-BC19-7A52DFEEB7AC}">
@@ -5108,8 +5126,8 @@
       </dsp:nvSpPr>
       <dsp:spPr>
         <a:xfrm>
-          <a:off x="7121649" y="1178"/>
-          <a:ext cx="2485132" cy="1242566"/>
+          <a:off x="7931002" y="4352"/>
+          <a:ext cx="2936890" cy="1468445"/>
         </a:xfrm>
         <a:prstGeom prst="roundRect">
           <a:avLst>
@@ -5153,12 +5171,12 @@
         </a:fontRef>
       </dsp:style>
       <dsp:txBody>
-        <a:bodyPr spcFirstLastPara="0" vert="horz" wrap="square" lIns="51435" tIns="34290" rIns="51435" bIns="34290" numCol="1" spcCol="1270" anchor="ctr" anchorCtr="0">
+        <a:bodyPr spcFirstLastPara="0" vert="horz" wrap="square" lIns="60960" tIns="40640" rIns="60960" bIns="40640" numCol="1" spcCol="1270" anchor="ctr" anchorCtr="0">
           <a:noAutofit/>
         </a:bodyPr>
         <a:lstStyle/>
         <a:p>
-          <a:pPr marL="0" lvl="0" indent="0" algn="ctr" defTabSz="1200150">
+          <a:pPr marL="0" lvl="0" indent="0" algn="ctr" defTabSz="1422400">
             <a:lnSpc>
               <a:spcPct val="90000"/>
             </a:lnSpc>
@@ -5171,14 +5189,14 @@
             <a:buNone/>
           </a:pPr>
           <a:r>
-            <a:rPr lang="en-US" sz="2700" kern="1200" dirty="0"/>
-            <a:t>Compound Building blocks</a:t>
+            <a:rPr lang="en-US" sz="3200" kern="1200" dirty="0"/>
+            <a:t>Composite Building blocks</a:t>
           </a:r>
         </a:p>
       </dsp:txBody>
       <dsp:txXfrm>
-        <a:off x="7158043" y="37572"/>
-        <a:ext cx="2412344" cy="1169778"/>
+        <a:off x="7974011" y="47361"/>
+        <a:ext cx="2850872" cy="1382427"/>
       </dsp:txXfrm>
     </dsp:sp>
     <dsp:sp modelId="{7F83A4BA-A114-4C38-B2AE-956851BE5CAD}">
@@ -5188,8 +5206,8 @@
       </dsp:nvSpPr>
       <dsp:spPr>
         <a:xfrm>
-          <a:off x="7370162" y="1243744"/>
-          <a:ext cx="248513" cy="931924"/>
+          <a:off x="8224691" y="1472797"/>
+          <a:ext cx="293689" cy="1101333"/>
         </a:xfrm>
         <a:custGeom>
           <a:avLst/>
@@ -5203,10 +5221,10 @@
                 <a:pt x="0" y="0"/>
               </a:moveTo>
               <a:lnTo>
-                <a:pt x="0" y="931924"/>
+                <a:pt x="0" y="1101333"/>
               </a:lnTo>
               <a:lnTo>
-                <a:pt x="248513" y="931924"/>
+                <a:pt x="293689" y="1101333"/>
               </a:lnTo>
             </a:path>
           </a:pathLst>
@@ -5247,8 +5265,8 @@
       </dsp:nvSpPr>
       <dsp:spPr>
         <a:xfrm>
-          <a:off x="7618675" y="1554385"/>
-          <a:ext cx="1988105" cy="1242566"/>
+          <a:off x="8518380" y="1839908"/>
+          <a:ext cx="2349512" cy="1468445"/>
         </a:xfrm>
         <a:prstGeom prst="roundRect">
           <a:avLst>
@@ -5291,12 +5309,12 @@
         <a:fontRef idx="minor"/>
       </dsp:style>
       <dsp:txBody>
-        <a:bodyPr spcFirstLastPara="0" vert="horz" wrap="square" lIns="55245" tIns="36830" rIns="55245" bIns="36830" numCol="1" spcCol="1270" anchor="ctr" anchorCtr="0">
+        <a:bodyPr spcFirstLastPara="0" vert="horz" wrap="square" lIns="66675" tIns="44450" rIns="66675" bIns="44450" numCol="1" spcCol="1270" anchor="ctr" anchorCtr="0">
           <a:noAutofit/>
         </a:bodyPr>
         <a:lstStyle/>
         <a:p>
-          <a:pPr marL="0" lvl="0" indent="0" algn="ctr" defTabSz="1289050">
+          <a:pPr marL="0" lvl="0" indent="0" algn="ctr" defTabSz="1555750">
             <a:lnSpc>
               <a:spcPct val="90000"/>
             </a:lnSpc>
@@ -5309,14 +5327,14 @@
             <a:buNone/>
           </a:pPr>
           <a:r>
-            <a:rPr lang="en-US" sz="2900" kern="1200" dirty="0"/>
+            <a:rPr lang="en-US" sz="3500" kern="1200" dirty="0"/>
             <a:t>Data structures</a:t>
           </a:r>
         </a:p>
       </dsp:txBody>
       <dsp:txXfrm>
-        <a:off x="7655069" y="1590779"/>
-        <a:ext cx="1915317" cy="1169778"/>
+        <a:off x="8561389" y="1882917"/>
+        <a:ext cx="2263494" cy="1382427"/>
       </dsp:txXfrm>
     </dsp:sp>
   </dsp:spTree>
@@ -23887,6 +23905,229 @@
       </p:grpSpPr>
       <p:sp>
         <p:nvSpPr>
+          <p:cNvPr id="10" name="Rectangle 9">
+            <a:extLst>
+              <a:ext uri="{FF2B5EF4-FFF2-40B4-BE49-F238E27FC236}">
+                <a16:creationId xmlns:a16="http://schemas.microsoft.com/office/drawing/2014/main" id="{A4AC5506-6312-4701-8D3C-40187889A947}"/>
+              </a:ext>
+              <a:ext uri="{C183D7F6-B498-43B3-948B-1728B52AA6E4}">
+                <adec:decorative xmlns:adec="http://schemas.microsoft.com/office/drawing/2017/decorative" val="1"/>
+              </a:ext>
+            </a:extLst>
+          </p:cNvPr>
+          <p:cNvSpPr>
+            <a:spLocks noGrp="1" noRot="1" noChangeAspect="1" noMove="1" noResize="1" noEditPoints="1" noAdjustHandles="1" noChangeArrowheads="1" noChangeShapeType="1" noTextEdit="1"/>
+          </p:cNvSpPr>
+          <p:nvPr>
+            <p:extLst>
+              <p:ext uri="{386F3935-93C4-4BCD-93E2-E3B085C9AB24}">
+                <p16:designElem xmlns:p16="http://schemas.microsoft.com/office/powerpoint/2015/main" val="1"/>
+              </p:ext>
+            </p:extLst>
+          </p:nvPr>
+        </p:nvSpPr>
+        <p:spPr>
+          <a:xfrm>
+            <a:off x="0" y="651752"/>
+            <a:ext cx="12192000" cy="736551"/>
+          </a:xfrm>
+          <a:prstGeom prst="rect">
+            <a:avLst/>
+          </a:prstGeom>
+          <a:solidFill>
+            <a:schemeClr val="tx1"/>
+          </a:solidFill>
+          <a:ln>
+            <a:noFill/>
+          </a:ln>
+        </p:spPr>
+        <p:style>
+          <a:lnRef idx="2">
+            <a:schemeClr val="accent1">
+              <a:shade val="50000"/>
+            </a:schemeClr>
+          </a:lnRef>
+          <a:fillRef idx="1">
+            <a:schemeClr val="accent1"/>
+          </a:fillRef>
+          <a:effectRef idx="0">
+            <a:schemeClr val="accent1"/>
+          </a:effectRef>
+          <a:fontRef idx="minor">
+            <a:schemeClr val="lt1"/>
+          </a:fontRef>
+        </p:style>
+        <p:txBody>
+          <a:bodyPr rtlCol="0" anchor="ctr"/>
+          <a:lstStyle/>
+          <a:p>
+            <a:pPr algn="ctr"/>
+            <a:endParaRPr lang="en-US"/>
+          </a:p>
+        </p:txBody>
+      </p:sp>
+      <p:sp>
+        <p:nvSpPr>
+          <p:cNvPr id="2" name="Title 1">
+            <a:extLst>
+              <a:ext uri="{FF2B5EF4-FFF2-40B4-BE49-F238E27FC236}">
+                <a16:creationId xmlns:a16="http://schemas.microsoft.com/office/drawing/2014/main" id="{FEE7ABFC-C699-A35D-9639-E4640C640631}"/>
+              </a:ext>
+            </a:extLst>
+          </p:cNvPr>
+          <p:cNvSpPr>
+            <a:spLocks noGrp="1"/>
+          </p:cNvSpPr>
+          <p:nvPr>
+            <p:ph type="title"/>
+          </p:nvPr>
+        </p:nvSpPr>
+        <p:spPr>
+          <a:xfrm>
+            <a:off x="556532" y="643467"/>
+            <a:ext cx="11210925" cy="744836"/>
+          </a:xfrm>
+        </p:spPr>
+        <p:txBody>
+          <a:bodyPr vert="horz" lIns="91440" tIns="45720" rIns="91440" bIns="45720" rtlCol="0" anchor="ctr">
+            <a:normAutofit/>
+          </a:bodyPr>
+          <a:lstStyle/>
+          <a:p>
+            <a:pPr algn="ctr"/>
+            <a:r>
+              <a:rPr lang="en-US" sz="3200" kern="1200">
+                <a:solidFill>
+                  <a:schemeClr val="bg1"/>
+                </a:solidFill>
+                <a:latin typeface="+mj-lt"/>
+                <a:ea typeface="+mj-ea"/>
+                <a:cs typeface="+mj-cs"/>
+              </a:rPr>
+              <a:t>Git</a:t>
+            </a:r>
+          </a:p>
+        </p:txBody>
+      </p:sp>
+      <p:pic>
+        <p:nvPicPr>
+          <p:cNvPr id="5" name="Content Placeholder 4" descr="A diagram of a tree&#10;&#10;AI-generated content may be incorrect.">
+            <a:extLst>
+              <a:ext uri="{FF2B5EF4-FFF2-40B4-BE49-F238E27FC236}">
+                <a16:creationId xmlns:a16="http://schemas.microsoft.com/office/drawing/2014/main" id="{9F735E43-58EF-CD32-150D-33D5773D6B53}"/>
+              </a:ext>
+            </a:extLst>
+          </p:cNvPr>
+          <p:cNvPicPr>
+            <a:picLocks noGrp="1" noChangeAspect="1"/>
+          </p:cNvPicPr>
+          <p:nvPr>
+            <p:ph idx="1"/>
+          </p:nvPr>
+        </p:nvPicPr>
+        <p:blipFill>
+          <a:blip r:embed="rId2">
+            <a:extLst>
+              <a:ext uri="{28A0092B-C50C-407E-A947-70E740481C1C}">
+                <a14:useLocalDpi xmlns:a14="http://schemas.microsoft.com/office/drawing/2010/main" val="0"/>
+              </a:ext>
+            </a:extLst>
+          </a:blip>
+          <a:stretch>
+            <a:fillRect/>
+          </a:stretch>
+        </p:blipFill>
+        <p:spPr>
+          <a:xfrm>
+            <a:off x="1841389" y="1480917"/>
+            <a:ext cx="8834231" cy="5035512"/>
+          </a:xfrm>
+          <a:prstGeom prst="rect">
+            <a:avLst/>
+          </a:prstGeom>
+        </p:spPr>
+      </p:pic>
+      <p:sp>
+        <p:nvSpPr>
+          <p:cNvPr id="6" name="TextBox 5">
+            <a:extLst>
+              <a:ext uri="{FF2B5EF4-FFF2-40B4-BE49-F238E27FC236}">
+                <a16:creationId xmlns:a16="http://schemas.microsoft.com/office/drawing/2014/main" id="{FED9FA4D-398A-0463-3626-7F54A3E5553A}"/>
+              </a:ext>
+            </a:extLst>
+          </p:cNvPr>
+          <p:cNvSpPr txBox="1"/>
+          <p:nvPr/>
+        </p:nvSpPr>
+        <p:spPr>
+          <a:xfrm>
+            <a:off x="880110" y="217170"/>
+            <a:ext cx="11228908" cy="646331"/>
+          </a:xfrm>
+          <a:prstGeom prst="rect">
+            <a:avLst/>
+          </a:prstGeom>
+          <a:noFill/>
+        </p:spPr>
+        <p:txBody>
+          <a:bodyPr wrap="none" rtlCol="0">
+            <a:spAutoFit/>
+          </a:bodyPr>
+          <a:lstStyle/>
+          <a:p>
+            <a:r>
+              <a:rPr lang="en-US" dirty="0">
+                <a:hlinkClick r:id="rId3"/>
+              </a:rPr>
+              <a:t>https://medium.com/@vivektikar/demystifying-git-what-is-a-git-branch-exactly-under-the-hood-b0a607ba1129</a:t>
+            </a:r>
+            <a:endParaRPr lang="en-US" dirty="0"/>
+          </a:p>
+          <a:p>
+            <a:endParaRPr lang="en-US" dirty="0"/>
+          </a:p>
+        </p:txBody>
+      </p:sp>
+    </p:spTree>
+    <p:extLst>
+      <p:ext uri="{BB962C8B-B14F-4D97-AF65-F5344CB8AC3E}">
+        <p14:creationId xmlns:p14="http://schemas.microsoft.com/office/powerpoint/2010/main" val="3278046040"/>
+      </p:ext>
+    </p:extLst>
+  </p:cSld>
+  <p:clrMapOvr>
+    <a:masterClrMapping/>
+  </p:clrMapOvr>
+</p:sld>
+</file>
+
+<file path=ppt/slides/slide28.xml><?xml version="1.0" encoding="utf-8"?>
+<p:sld xmlns:a="http://schemas.openxmlformats.org/drawingml/2006/main" xmlns:r="http://schemas.openxmlformats.org/officeDocument/2006/relationships" xmlns:p="http://schemas.openxmlformats.org/presentationml/2006/main">
+  <p:cSld>
+    <p:bg>
+      <p:bgPr>
+        <a:solidFill>
+          <a:schemeClr val="bg1"/>
+        </a:solidFill>
+        <a:effectLst/>
+      </p:bgPr>
+    </p:bg>
+    <p:spTree>
+      <p:nvGrpSpPr>
+        <p:cNvPr id="1" name=""/>
+        <p:cNvGrpSpPr/>
+        <p:nvPr/>
+      </p:nvGrpSpPr>
+      <p:grpSpPr>
+        <a:xfrm>
+          <a:off x="0" y="0"/>
+          <a:ext cx="0" cy="0"/>
+          <a:chOff x="0" y="0"/>
+          <a:chExt cx="0" cy="0"/>
+        </a:xfrm>
+      </p:grpSpPr>
+      <p:sp>
+        <p:nvSpPr>
           <p:cNvPr id="2" name="Title 1">
             <a:extLst>
               <a:ext uri="{FF2B5EF4-FFF2-40B4-BE49-F238E27FC236}">
@@ -24146,7 +24387,7 @@
 </p:sld>
 </file>
 
-<file path=ppt/slides/slide28.xml><?xml version="1.0" encoding="utf-8"?>
+<file path=ppt/slides/slide29.xml><?xml version="1.0" encoding="utf-8"?>
 <p:sld xmlns:a="http://schemas.openxmlformats.org/drawingml/2006/main" xmlns:r="http://schemas.openxmlformats.org/officeDocument/2006/relationships" xmlns:p="http://schemas.openxmlformats.org/presentationml/2006/main">
   <p:cSld>
     <p:bg>
@@ -24784,7 +25025,274 @@
 </p:sld>
 </file>
 
-<file path=ppt/slides/slide29.xml><?xml version="1.0" encoding="utf-8"?>
+<file path=ppt/slides/slide3.xml><?xml version="1.0" encoding="utf-8"?>
+<p:sld xmlns:a="http://schemas.openxmlformats.org/drawingml/2006/main" xmlns:r="http://schemas.openxmlformats.org/officeDocument/2006/relationships" xmlns:p="http://schemas.openxmlformats.org/presentationml/2006/main">
+  <p:cSld>
+    <p:bg>
+      <p:bgPr>
+        <a:solidFill>
+          <a:schemeClr val="bg1"/>
+        </a:solidFill>
+        <a:effectLst/>
+      </p:bgPr>
+    </p:bg>
+    <p:spTree>
+      <p:nvGrpSpPr>
+        <p:cNvPr id="1" name=""/>
+        <p:cNvGrpSpPr/>
+        <p:nvPr/>
+      </p:nvGrpSpPr>
+      <p:grpSpPr>
+        <a:xfrm>
+          <a:off x="0" y="0"/>
+          <a:ext cx="0" cy="0"/>
+          <a:chOff x="0" y="0"/>
+          <a:chExt cx="0" cy="0"/>
+        </a:xfrm>
+      </p:grpSpPr>
+      <p:sp useBgFill="1">
+        <p:nvSpPr>
+          <p:cNvPr id="9" name="Rectangle 8">
+            <a:extLst>
+              <a:ext uri="{FF2B5EF4-FFF2-40B4-BE49-F238E27FC236}">
+                <a16:creationId xmlns:a16="http://schemas.microsoft.com/office/drawing/2014/main" id="{C1DD1A8A-57D5-4A81-AD04-532B043C5611}"/>
+              </a:ext>
+              <a:ext uri="{C183D7F6-B498-43B3-948B-1728B52AA6E4}">
+                <adec:decorative xmlns:adec="http://schemas.microsoft.com/office/drawing/2017/decorative" val="1"/>
+              </a:ext>
+            </a:extLst>
+          </p:cNvPr>
+          <p:cNvSpPr>
+            <a:spLocks noGrp="1" noRot="1" noChangeAspect="1" noMove="1" noResize="1" noEditPoints="1" noAdjustHandles="1" noChangeArrowheads="1" noChangeShapeType="1" noTextEdit="1"/>
+          </p:cNvSpPr>
+          <p:nvPr>
+            <p:extLst>
+              <p:ext uri="{386F3935-93C4-4BCD-93E2-E3B085C9AB24}">
+                <p16:designElem xmlns:p16="http://schemas.microsoft.com/office/powerpoint/2015/main" val="1"/>
+              </p:ext>
+            </p:extLst>
+          </p:nvPr>
+        </p:nvSpPr>
+        <p:spPr>
+          <a:xfrm>
+            <a:off x="-1" y="0"/>
+            <a:ext cx="12188952" cy="6858000"/>
+          </a:xfrm>
+          <a:prstGeom prst="rect">
+            <a:avLst/>
+          </a:prstGeom>
+          <a:ln>
+            <a:noFill/>
+          </a:ln>
+        </p:spPr>
+        <p:style>
+          <a:lnRef idx="2">
+            <a:schemeClr val="accent1">
+              <a:shade val="50000"/>
+            </a:schemeClr>
+          </a:lnRef>
+          <a:fillRef idx="1">
+            <a:schemeClr val="accent1"/>
+          </a:fillRef>
+          <a:effectRef idx="0">
+            <a:schemeClr val="accent1"/>
+          </a:effectRef>
+          <a:fontRef idx="minor">
+            <a:schemeClr val="lt1"/>
+          </a:fontRef>
+        </p:style>
+        <p:txBody>
+          <a:bodyPr rtlCol="0" anchor="ctr"/>
+          <a:lstStyle/>
+          <a:p>
+            <a:pPr algn="ctr"/>
+            <a:endParaRPr lang="en-US"/>
+          </a:p>
+        </p:txBody>
+      </p:sp>
+      <p:pic>
+        <p:nvPicPr>
+          <p:cNvPr id="5" name="Picture 4" descr="Draft drawing of a floor plan">
+            <a:extLst>
+              <a:ext uri="{FF2B5EF4-FFF2-40B4-BE49-F238E27FC236}">
+                <a16:creationId xmlns:a16="http://schemas.microsoft.com/office/drawing/2014/main" id="{517E5618-77FE-B396-6AA5-93F54910184A}"/>
+              </a:ext>
+            </a:extLst>
+          </p:cNvPr>
+          <p:cNvPicPr>
+            <a:picLocks noChangeAspect="1"/>
+          </p:cNvPicPr>
+          <p:nvPr/>
+        </p:nvPicPr>
+        <p:blipFill>
+          <a:blip r:embed="rId2"/>
+          <a:srcRect t="7602" b="10877"/>
+          <a:stretch>
+            <a:fillRect/>
+          </a:stretch>
+        </p:blipFill>
+        <p:spPr>
+          <a:xfrm>
+            <a:off x="-3047" y="10"/>
+            <a:ext cx="12191999" cy="6857990"/>
+          </a:xfrm>
+          <a:prstGeom prst="rect">
+            <a:avLst/>
+          </a:prstGeom>
+        </p:spPr>
+      </p:pic>
+      <p:sp>
+        <p:nvSpPr>
+          <p:cNvPr id="11" name="Rectangle 10">
+            <a:extLst>
+              <a:ext uri="{FF2B5EF4-FFF2-40B4-BE49-F238E27FC236}">
+                <a16:creationId xmlns:a16="http://schemas.microsoft.com/office/drawing/2014/main" id="{007891EC-4501-44ED-A8C8-B11B6DB767AB}"/>
+              </a:ext>
+              <a:ext uri="{C183D7F6-B498-43B3-948B-1728B52AA6E4}">
+                <adec:decorative xmlns:adec="http://schemas.microsoft.com/office/drawing/2017/decorative" val="1"/>
+              </a:ext>
+            </a:extLst>
+          </p:cNvPr>
+          <p:cNvSpPr>
+            <a:spLocks noGrp="1" noRot="1" noChangeAspect="1" noMove="1" noResize="1" noEditPoints="1" noAdjustHandles="1" noChangeArrowheads="1" noChangeShapeType="1" noTextEdit="1"/>
+          </p:cNvSpPr>
+          <p:nvPr>
+            <p:extLst>
+              <p:ext uri="{386F3935-93C4-4BCD-93E2-E3B085C9AB24}">
+                <p16:designElem xmlns:p16="http://schemas.microsoft.com/office/powerpoint/2015/main" val="1"/>
+              </p:ext>
+            </p:extLst>
+          </p:nvPr>
+        </p:nvSpPr>
+        <p:spPr>
+          <a:xfrm>
+            <a:off x="0" y="2207602"/>
+            <a:ext cx="12191999" cy="3162146"/>
+          </a:xfrm>
+          <a:prstGeom prst="rect">
+            <a:avLst/>
+          </a:prstGeom>
+          <a:gradFill flip="none" rotWithShape="1">
+            <a:gsLst>
+              <a:gs pos="0">
+                <a:srgbClr val="000000">
+                  <a:alpha val="0"/>
+                </a:srgbClr>
+              </a:gs>
+              <a:gs pos="25000">
+                <a:srgbClr val="000000">
+                  <a:alpha val="15000"/>
+                </a:srgbClr>
+              </a:gs>
+              <a:gs pos="75000">
+                <a:srgbClr val="000000">
+                  <a:alpha val="15000"/>
+                </a:srgbClr>
+              </a:gs>
+              <a:gs pos="50000">
+                <a:srgbClr val="000000">
+                  <a:alpha val="30000"/>
+                </a:srgbClr>
+              </a:gs>
+              <a:gs pos="100000">
+                <a:srgbClr val="000000">
+                  <a:alpha val="0"/>
+                </a:srgbClr>
+              </a:gs>
+            </a:gsLst>
+            <a:lin ang="16200000" scaled="1"/>
+            <a:tileRect/>
+          </a:gradFill>
+          <a:ln>
+            <a:noFill/>
+          </a:ln>
+        </p:spPr>
+        <p:style>
+          <a:lnRef idx="2">
+            <a:schemeClr val="accent1">
+              <a:shade val="50000"/>
+            </a:schemeClr>
+          </a:lnRef>
+          <a:fillRef idx="1">
+            <a:schemeClr val="accent1"/>
+          </a:fillRef>
+          <a:effectRef idx="0">
+            <a:schemeClr val="accent1"/>
+          </a:effectRef>
+          <a:fontRef idx="minor">
+            <a:schemeClr val="lt1"/>
+          </a:fontRef>
+        </p:style>
+        <p:txBody>
+          <a:bodyPr rtlCol="0" anchor="ctr"/>
+          <a:lstStyle/>
+          <a:p>
+            <a:pPr algn="ctr"/>
+            <a:endParaRPr lang="en-US"/>
+          </a:p>
+        </p:txBody>
+      </p:sp>
+      <p:sp>
+        <p:nvSpPr>
+          <p:cNvPr id="2" name="Title 1">
+            <a:extLst>
+              <a:ext uri="{FF2B5EF4-FFF2-40B4-BE49-F238E27FC236}">
+                <a16:creationId xmlns:a16="http://schemas.microsoft.com/office/drawing/2014/main" id="{EC613D61-89EC-866E-6C45-6C859ACD1005}"/>
+              </a:ext>
+            </a:extLst>
+          </p:cNvPr>
+          <p:cNvSpPr>
+            <a:spLocks noGrp="1"/>
+          </p:cNvSpPr>
+          <p:nvPr>
+            <p:ph type="title"/>
+          </p:nvPr>
+        </p:nvSpPr>
+        <p:spPr>
+          <a:xfrm>
+            <a:off x="1097280" y="325550"/>
+            <a:ext cx="10058400" cy="3574778"/>
+          </a:xfrm>
+          <a:effectLst>
+            <a:outerShdw blurRad="50800" dist="38100" dir="2700000" algn="tl" rotWithShape="0">
+              <a:prstClr val="black">
+                <a:alpha val="40000"/>
+              </a:prstClr>
+            </a:outerShdw>
+          </a:effectLst>
+        </p:spPr>
+        <p:txBody>
+          <a:bodyPr vert="horz" lIns="91440" tIns="45720" rIns="91440" bIns="45720" rtlCol="0" anchor="b">
+            <a:normAutofit/>
+          </a:bodyPr>
+          <a:lstStyle/>
+          <a:p>
+            <a:pPr algn="ctr"/>
+            <a:r>
+              <a:rPr lang="en-US" sz="5200" dirty="0">
+                <a:solidFill>
+                  <a:srgbClr val="FFFFFF"/>
+                </a:solidFill>
+              </a:rPr>
+              <a:t>The blueprint – an algorithm</a:t>
+            </a:r>
+          </a:p>
+        </p:txBody>
+      </p:sp>
+    </p:spTree>
+    <p:extLst>
+      <p:ext uri="{BB962C8B-B14F-4D97-AF65-F5344CB8AC3E}">
+        <p14:creationId xmlns:p14="http://schemas.microsoft.com/office/powerpoint/2010/main" val="3740388368"/>
+      </p:ext>
+    </p:extLst>
+  </p:cSld>
+  <p:clrMapOvr>
+    <a:masterClrMapping/>
+  </p:clrMapOvr>
+</p:sld>
+</file>
+
+<file path=ppt/slides/slide30.xml><?xml version="1.0" encoding="utf-8"?>
 <p:sld xmlns:a="http://schemas.openxmlformats.org/drawingml/2006/main" xmlns:r="http://schemas.openxmlformats.org/officeDocument/2006/relationships" xmlns:p="http://schemas.openxmlformats.org/presentationml/2006/main">
   <p:cSld>
     <p:bg>
@@ -25520,274 +26028,7 @@
 </p:sld>
 </file>
 
-<file path=ppt/slides/slide3.xml><?xml version="1.0" encoding="utf-8"?>
-<p:sld xmlns:a="http://schemas.openxmlformats.org/drawingml/2006/main" xmlns:r="http://schemas.openxmlformats.org/officeDocument/2006/relationships" xmlns:p="http://schemas.openxmlformats.org/presentationml/2006/main">
-  <p:cSld>
-    <p:bg>
-      <p:bgPr>
-        <a:solidFill>
-          <a:schemeClr val="bg1"/>
-        </a:solidFill>
-        <a:effectLst/>
-      </p:bgPr>
-    </p:bg>
-    <p:spTree>
-      <p:nvGrpSpPr>
-        <p:cNvPr id="1" name=""/>
-        <p:cNvGrpSpPr/>
-        <p:nvPr/>
-      </p:nvGrpSpPr>
-      <p:grpSpPr>
-        <a:xfrm>
-          <a:off x="0" y="0"/>
-          <a:ext cx="0" cy="0"/>
-          <a:chOff x="0" y="0"/>
-          <a:chExt cx="0" cy="0"/>
-        </a:xfrm>
-      </p:grpSpPr>
-      <p:sp useBgFill="1">
-        <p:nvSpPr>
-          <p:cNvPr id="9" name="Rectangle 8">
-            <a:extLst>
-              <a:ext uri="{FF2B5EF4-FFF2-40B4-BE49-F238E27FC236}">
-                <a16:creationId xmlns:a16="http://schemas.microsoft.com/office/drawing/2014/main" id="{C1DD1A8A-57D5-4A81-AD04-532B043C5611}"/>
-              </a:ext>
-              <a:ext uri="{C183D7F6-B498-43B3-948B-1728B52AA6E4}">
-                <adec:decorative xmlns:adec="http://schemas.microsoft.com/office/drawing/2017/decorative" val="1"/>
-              </a:ext>
-            </a:extLst>
-          </p:cNvPr>
-          <p:cNvSpPr>
-            <a:spLocks noGrp="1" noRot="1" noChangeAspect="1" noMove="1" noResize="1" noEditPoints="1" noAdjustHandles="1" noChangeArrowheads="1" noChangeShapeType="1" noTextEdit="1"/>
-          </p:cNvSpPr>
-          <p:nvPr>
-            <p:extLst>
-              <p:ext uri="{386F3935-93C4-4BCD-93E2-E3B085C9AB24}">
-                <p16:designElem xmlns:p16="http://schemas.microsoft.com/office/powerpoint/2015/main" val="1"/>
-              </p:ext>
-            </p:extLst>
-          </p:nvPr>
-        </p:nvSpPr>
-        <p:spPr>
-          <a:xfrm>
-            <a:off x="-1" y="0"/>
-            <a:ext cx="12188952" cy="6858000"/>
-          </a:xfrm>
-          <a:prstGeom prst="rect">
-            <a:avLst/>
-          </a:prstGeom>
-          <a:ln>
-            <a:noFill/>
-          </a:ln>
-        </p:spPr>
-        <p:style>
-          <a:lnRef idx="2">
-            <a:schemeClr val="accent1">
-              <a:shade val="50000"/>
-            </a:schemeClr>
-          </a:lnRef>
-          <a:fillRef idx="1">
-            <a:schemeClr val="accent1"/>
-          </a:fillRef>
-          <a:effectRef idx="0">
-            <a:schemeClr val="accent1"/>
-          </a:effectRef>
-          <a:fontRef idx="minor">
-            <a:schemeClr val="lt1"/>
-          </a:fontRef>
-        </p:style>
-        <p:txBody>
-          <a:bodyPr rtlCol="0" anchor="ctr"/>
-          <a:lstStyle/>
-          <a:p>
-            <a:pPr algn="ctr"/>
-            <a:endParaRPr lang="en-US"/>
-          </a:p>
-        </p:txBody>
-      </p:sp>
-      <p:pic>
-        <p:nvPicPr>
-          <p:cNvPr id="5" name="Picture 4" descr="Draft drawing of a floor plan">
-            <a:extLst>
-              <a:ext uri="{FF2B5EF4-FFF2-40B4-BE49-F238E27FC236}">
-                <a16:creationId xmlns:a16="http://schemas.microsoft.com/office/drawing/2014/main" id="{517E5618-77FE-B396-6AA5-93F54910184A}"/>
-              </a:ext>
-            </a:extLst>
-          </p:cNvPr>
-          <p:cNvPicPr>
-            <a:picLocks noChangeAspect="1"/>
-          </p:cNvPicPr>
-          <p:nvPr/>
-        </p:nvPicPr>
-        <p:blipFill>
-          <a:blip r:embed="rId2"/>
-          <a:srcRect t="7602" b="10877"/>
-          <a:stretch>
-            <a:fillRect/>
-          </a:stretch>
-        </p:blipFill>
-        <p:spPr>
-          <a:xfrm>
-            <a:off x="-3047" y="10"/>
-            <a:ext cx="12191999" cy="6857990"/>
-          </a:xfrm>
-          <a:prstGeom prst="rect">
-            <a:avLst/>
-          </a:prstGeom>
-        </p:spPr>
-      </p:pic>
-      <p:sp>
-        <p:nvSpPr>
-          <p:cNvPr id="11" name="Rectangle 10">
-            <a:extLst>
-              <a:ext uri="{FF2B5EF4-FFF2-40B4-BE49-F238E27FC236}">
-                <a16:creationId xmlns:a16="http://schemas.microsoft.com/office/drawing/2014/main" id="{007891EC-4501-44ED-A8C8-B11B6DB767AB}"/>
-              </a:ext>
-              <a:ext uri="{C183D7F6-B498-43B3-948B-1728B52AA6E4}">
-                <adec:decorative xmlns:adec="http://schemas.microsoft.com/office/drawing/2017/decorative" val="1"/>
-              </a:ext>
-            </a:extLst>
-          </p:cNvPr>
-          <p:cNvSpPr>
-            <a:spLocks noGrp="1" noRot="1" noChangeAspect="1" noMove="1" noResize="1" noEditPoints="1" noAdjustHandles="1" noChangeArrowheads="1" noChangeShapeType="1" noTextEdit="1"/>
-          </p:cNvSpPr>
-          <p:nvPr>
-            <p:extLst>
-              <p:ext uri="{386F3935-93C4-4BCD-93E2-E3B085C9AB24}">
-                <p16:designElem xmlns:p16="http://schemas.microsoft.com/office/powerpoint/2015/main" val="1"/>
-              </p:ext>
-            </p:extLst>
-          </p:nvPr>
-        </p:nvSpPr>
-        <p:spPr>
-          <a:xfrm>
-            <a:off x="0" y="2207602"/>
-            <a:ext cx="12191999" cy="3162146"/>
-          </a:xfrm>
-          <a:prstGeom prst="rect">
-            <a:avLst/>
-          </a:prstGeom>
-          <a:gradFill flip="none" rotWithShape="1">
-            <a:gsLst>
-              <a:gs pos="0">
-                <a:srgbClr val="000000">
-                  <a:alpha val="0"/>
-                </a:srgbClr>
-              </a:gs>
-              <a:gs pos="25000">
-                <a:srgbClr val="000000">
-                  <a:alpha val="15000"/>
-                </a:srgbClr>
-              </a:gs>
-              <a:gs pos="75000">
-                <a:srgbClr val="000000">
-                  <a:alpha val="15000"/>
-                </a:srgbClr>
-              </a:gs>
-              <a:gs pos="50000">
-                <a:srgbClr val="000000">
-                  <a:alpha val="30000"/>
-                </a:srgbClr>
-              </a:gs>
-              <a:gs pos="100000">
-                <a:srgbClr val="000000">
-                  <a:alpha val="0"/>
-                </a:srgbClr>
-              </a:gs>
-            </a:gsLst>
-            <a:lin ang="16200000" scaled="1"/>
-            <a:tileRect/>
-          </a:gradFill>
-          <a:ln>
-            <a:noFill/>
-          </a:ln>
-        </p:spPr>
-        <p:style>
-          <a:lnRef idx="2">
-            <a:schemeClr val="accent1">
-              <a:shade val="50000"/>
-            </a:schemeClr>
-          </a:lnRef>
-          <a:fillRef idx="1">
-            <a:schemeClr val="accent1"/>
-          </a:fillRef>
-          <a:effectRef idx="0">
-            <a:schemeClr val="accent1"/>
-          </a:effectRef>
-          <a:fontRef idx="minor">
-            <a:schemeClr val="lt1"/>
-          </a:fontRef>
-        </p:style>
-        <p:txBody>
-          <a:bodyPr rtlCol="0" anchor="ctr"/>
-          <a:lstStyle/>
-          <a:p>
-            <a:pPr algn="ctr"/>
-            <a:endParaRPr lang="en-US"/>
-          </a:p>
-        </p:txBody>
-      </p:sp>
-      <p:sp>
-        <p:nvSpPr>
-          <p:cNvPr id="2" name="Title 1">
-            <a:extLst>
-              <a:ext uri="{FF2B5EF4-FFF2-40B4-BE49-F238E27FC236}">
-                <a16:creationId xmlns:a16="http://schemas.microsoft.com/office/drawing/2014/main" id="{EC613D61-89EC-866E-6C45-6C859ACD1005}"/>
-              </a:ext>
-            </a:extLst>
-          </p:cNvPr>
-          <p:cNvSpPr>
-            <a:spLocks noGrp="1"/>
-          </p:cNvSpPr>
-          <p:nvPr>
-            <p:ph type="title"/>
-          </p:nvPr>
-        </p:nvSpPr>
-        <p:spPr>
-          <a:xfrm>
-            <a:off x="1097280" y="325550"/>
-            <a:ext cx="10058400" cy="3574778"/>
-          </a:xfrm>
-          <a:effectLst>
-            <a:outerShdw blurRad="50800" dist="38100" dir="2700000" algn="tl" rotWithShape="0">
-              <a:prstClr val="black">
-                <a:alpha val="40000"/>
-              </a:prstClr>
-            </a:outerShdw>
-          </a:effectLst>
-        </p:spPr>
-        <p:txBody>
-          <a:bodyPr vert="horz" lIns="91440" tIns="45720" rIns="91440" bIns="45720" rtlCol="0" anchor="b">
-            <a:normAutofit/>
-          </a:bodyPr>
-          <a:lstStyle/>
-          <a:p>
-            <a:pPr algn="ctr"/>
-            <a:r>
-              <a:rPr lang="en-US" sz="5200" dirty="0">
-                <a:solidFill>
-                  <a:srgbClr val="FFFFFF"/>
-                </a:solidFill>
-              </a:rPr>
-              <a:t>The blueprint – an algorithm</a:t>
-            </a:r>
-          </a:p>
-        </p:txBody>
-      </p:sp>
-    </p:spTree>
-    <p:extLst>
-      <p:ext uri="{BB962C8B-B14F-4D97-AF65-F5344CB8AC3E}">
-        <p14:creationId xmlns:p14="http://schemas.microsoft.com/office/powerpoint/2010/main" val="3740388368"/>
-      </p:ext>
-    </p:extLst>
-  </p:cSld>
-  <p:clrMapOvr>
-    <a:masterClrMapping/>
-  </p:clrMapOvr>
-</p:sld>
-</file>
-
-<file path=ppt/slides/slide30.xml><?xml version="1.0" encoding="utf-8"?>
+<file path=ppt/slides/slide31.xml><?xml version="1.0" encoding="utf-8"?>
 <p:sld xmlns:a="http://schemas.openxmlformats.org/drawingml/2006/main" xmlns:r="http://schemas.openxmlformats.org/officeDocument/2006/relationships" xmlns:p="http://schemas.openxmlformats.org/presentationml/2006/main">
   <p:cSld>
     <p:bg>
@@ -26523,7 +26764,7 @@
 </p:sld>
 </file>
 
-<file path=ppt/slides/slide31.xml><?xml version="1.0" encoding="utf-8"?>
+<file path=ppt/slides/slide32.xml><?xml version="1.0" encoding="utf-8"?>
 <p:sld xmlns:a="http://schemas.openxmlformats.org/drawingml/2006/main" xmlns:r="http://schemas.openxmlformats.org/officeDocument/2006/relationships" xmlns:p="http://schemas.openxmlformats.org/presentationml/2006/main">
   <p:cSld>
     <p:bg>
@@ -26663,7 +26904,7 @@
 </p:sld>
 </file>
 
-<file path=ppt/slides/slide32.xml><?xml version="1.0" encoding="utf-8"?>
+<file path=ppt/slides/slide33.xml><?xml version="1.0" encoding="utf-8"?>
 <p:sld xmlns:a="http://schemas.openxmlformats.org/drawingml/2006/main" xmlns:r="http://schemas.openxmlformats.org/officeDocument/2006/relationships" xmlns:p="http://schemas.openxmlformats.org/presentationml/2006/main">
   <p:cSld>
     <p:bg>
@@ -27307,7 +27548,7 @@
 </p:sld>
 </file>
 
-<file path=ppt/slides/slide33.xml><?xml version="1.0" encoding="utf-8"?>
+<file path=ppt/slides/slide34.xml><?xml version="1.0" encoding="utf-8"?>
 <p:sld xmlns:a="http://schemas.openxmlformats.org/drawingml/2006/main" xmlns:r="http://schemas.openxmlformats.org/officeDocument/2006/relationships" xmlns:p="http://schemas.openxmlformats.org/presentationml/2006/main">
   <p:cSld>
     <p:bg>
@@ -27748,7 +27989,7 @@
 </p:sld>
 </file>
 
-<file path=ppt/slides/slide34.xml><?xml version="1.0" encoding="utf-8"?>
+<file path=ppt/slides/slide35.xml><?xml version="1.0" encoding="utf-8"?>
 <p:sld xmlns:a="http://schemas.openxmlformats.org/drawingml/2006/main" xmlns:r="http://schemas.openxmlformats.org/officeDocument/2006/relationships" xmlns:p="http://schemas.openxmlformats.org/presentationml/2006/main">
   <p:cSld>
     <p:spTree>
@@ -27922,7 +28163,7 @@
 </p:sld>
 </file>
 
-<file path=ppt/slides/slide35.xml><?xml version="1.0" encoding="utf-8"?>
+<file path=ppt/slides/slide36.xml><?xml version="1.0" encoding="utf-8"?>
 <p:sld xmlns:a="http://schemas.openxmlformats.org/drawingml/2006/main" xmlns:r="http://schemas.openxmlformats.org/officeDocument/2006/relationships" xmlns:p="http://schemas.openxmlformats.org/presentationml/2006/main">
   <p:cSld>
     <p:spTree>
@@ -28156,7 +28397,7 @@
 </p:sld>
 </file>
 
-<file path=ppt/slides/slide36.xml><?xml version="1.0" encoding="utf-8"?>
+<file path=ppt/slides/slide37.xml><?xml version="1.0" encoding="utf-8"?>
 <p:sld xmlns:a="http://schemas.openxmlformats.org/drawingml/2006/main" xmlns:r="http://schemas.openxmlformats.org/officeDocument/2006/relationships" xmlns:p="http://schemas.openxmlformats.org/presentationml/2006/main">
   <p:cSld>
     <p:bg>
@@ -28612,7 +28853,7 @@
 </p:sld>
 </file>
 
-<file path=ppt/slides/slide37.xml><?xml version="1.0" encoding="utf-8"?>
+<file path=ppt/slides/slide38.xml><?xml version="1.0" encoding="utf-8"?>
 <p:sld xmlns:a="http://schemas.openxmlformats.org/drawingml/2006/main" xmlns:r="http://schemas.openxmlformats.org/officeDocument/2006/relationships" xmlns:p="http://schemas.openxmlformats.org/presentationml/2006/main">
   <p:cSld>
     <p:spTree>
@@ -28807,7 +29048,7 @@
 </p:sld>
 </file>
 
-<file path=ppt/slides/slide38.xml><?xml version="1.0" encoding="utf-8"?>
+<file path=ppt/slides/slide39.xml><?xml version="1.0" encoding="utf-8"?>
 <p:sld xmlns:a="http://schemas.openxmlformats.org/drawingml/2006/main" xmlns:r="http://schemas.openxmlformats.org/officeDocument/2006/relationships" xmlns:p="http://schemas.openxmlformats.org/presentationml/2006/main">
   <p:cSld>
     <p:bg>
@@ -29059,71 +29300,6 @@
     <p:extLst>
       <p:ext uri="{BB962C8B-B14F-4D97-AF65-F5344CB8AC3E}">
         <p14:creationId xmlns:p14="http://schemas.microsoft.com/office/powerpoint/2010/main" val="1079636121"/>
-      </p:ext>
-    </p:extLst>
-  </p:cSld>
-  <p:clrMapOvr>
-    <a:masterClrMapping/>
-  </p:clrMapOvr>
-</p:sld>
-</file>
-
-<file path=ppt/slides/slide39.xml><?xml version="1.0" encoding="utf-8"?>
-<p:sld xmlns:a="http://schemas.openxmlformats.org/drawingml/2006/main" xmlns:r="http://schemas.openxmlformats.org/officeDocument/2006/relationships" xmlns:p="http://schemas.openxmlformats.org/presentationml/2006/main">
-  <p:cSld>
-    <p:spTree>
-      <p:nvGrpSpPr>
-        <p:cNvPr id="1" name=""/>
-        <p:cNvGrpSpPr/>
-        <p:nvPr/>
-      </p:nvGrpSpPr>
-      <p:grpSpPr>
-        <a:xfrm>
-          <a:off x="0" y="0"/>
-          <a:ext cx="0" cy="0"/>
-          <a:chOff x="0" y="0"/>
-          <a:chExt cx="0" cy="0"/>
-        </a:xfrm>
-      </p:grpSpPr>
-      <p:pic>
-        <p:nvPicPr>
-          <p:cNvPr id="5" name="Content Placeholder 4" descr="A number in a row&#10;&#10;AI-generated content may be incorrect.">
-            <a:extLst>
-              <a:ext uri="{FF2B5EF4-FFF2-40B4-BE49-F238E27FC236}">
-                <a16:creationId xmlns:a16="http://schemas.microsoft.com/office/drawing/2014/main" id="{EDF2404F-36D0-578D-93B9-A67F33EDFE06}"/>
-              </a:ext>
-            </a:extLst>
-          </p:cNvPr>
-          <p:cNvPicPr>
-            <a:picLocks noGrp="1" noChangeAspect="1"/>
-          </p:cNvPicPr>
-          <p:nvPr>
-            <p:ph idx="1"/>
-          </p:nvPr>
-        </p:nvPicPr>
-        <p:blipFill>
-          <a:blip r:embed="rId2">
-            <a:extLst>
-              <a:ext uri="{28A0092B-C50C-407E-A947-70E740481C1C}">
-                <a14:useLocalDpi xmlns:a14="http://schemas.microsoft.com/office/drawing/2010/main" val="0"/>
-              </a:ext>
-            </a:extLst>
-          </a:blip>
-          <a:stretch>
-            <a:fillRect/>
-          </a:stretch>
-        </p:blipFill>
-        <p:spPr>
-          <a:xfrm>
-            <a:off x="1575472" y="1603630"/>
-            <a:ext cx="9041055" cy="2644266"/>
-          </a:xfrm>
-        </p:spPr>
-      </p:pic>
-    </p:spTree>
-    <p:extLst>
-      <p:ext uri="{BB962C8B-B14F-4D97-AF65-F5344CB8AC3E}">
-        <p14:creationId xmlns:p14="http://schemas.microsoft.com/office/powerpoint/2010/main" val="2231824513"/>
       </p:ext>
     </p:extLst>
   </p:cSld>
@@ -29562,6 +29738,71 @@
       </p:grpSpPr>
       <p:pic>
         <p:nvPicPr>
+          <p:cNvPr id="5" name="Content Placeholder 4" descr="A number in a row&#10;&#10;AI-generated content may be incorrect.">
+            <a:extLst>
+              <a:ext uri="{FF2B5EF4-FFF2-40B4-BE49-F238E27FC236}">
+                <a16:creationId xmlns:a16="http://schemas.microsoft.com/office/drawing/2014/main" id="{EDF2404F-36D0-578D-93B9-A67F33EDFE06}"/>
+              </a:ext>
+            </a:extLst>
+          </p:cNvPr>
+          <p:cNvPicPr>
+            <a:picLocks noGrp="1" noChangeAspect="1"/>
+          </p:cNvPicPr>
+          <p:nvPr>
+            <p:ph idx="1"/>
+          </p:nvPr>
+        </p:nvPicPr>
+        <p:blipFill>
+          <a:blip r:embed="rId2">
+            <a:extLst>
+              <a:ext uri="{28A0092B-C50C-407E-A947-70E740481C1C}">
+                <a14:useLocalDpi xmlns:a14="http://schemas.microsoft.com/office/drawing/2010/main" val="0"/>
+              </a:ext>
+            </a:extLst>
+          </a:blip>
+          <a:stretch>
+            <a:fillRect/>
+          </a:stretch>
+        </p:blipFill>
+        <p:spPr>
+          <a:xfrm>
+            <a:off x="1575472" y="1603630"/>
+            <a:ext cx="9041055" cy="2644266"/>
+          </a:xfrm>
+        </p:spPr>
+      </p:pic>
+    </p:spTree>
+    <p:extLst>
+      <p:ext uri="{BB962C8B-B14F-4D97-AF65-F5344CB8AC3E}">
+        <p14:creationId xmlns:p14="http://schemas.microsoft.com/office/powerpoint/2010/main" val="2231824513"/>
+      </p:ext>
+    </p:extLst>
+  </p:cSld>
+  <p:clrMapOvr>
+    <a:masterClrMapping/>
+  </p:clrMapOvr>
+</p:sld>
+</file>
+
+<file path=ppt/slides/slide41.xml><?xml version="1.0" encoding="utf-8"?>
+<p:sld xmlns:a="http://schemas.openxmlformats.org/drawingml/2006/main" xmlns:r="http://schemas.openxmlformats.org/officeDocument/2006/relationships" xmlns:p="http://schemas.openxmlformats.org/presentationml/2006/main">
+  <p:cSld>
+    <p:spTree>
+      <p:nvGrpSpPr>
+        <p:cNvPr id="1" name=""/>
+        <p:cNvGrpSpPr/>
+        <p:nvPr/>
+      </p:nvGrpSpPr>
+      <p:grpSpPr>
+        <a:xfrm>
+          <a:off x="0" y="0"/>
+          <a:ext cx="0" cy="0"/>
+          <a:chOff x="0" y="0"/>
+          <a:chExt cx="0" cy="0"/>
+        </a:xfrm>
+      </p:grpSpPr>
+      <p:pic>
+        <p:nvPicPr>
           <p:cNvPr id="5" name="Content Placeholder 4" descr="A diagram of a triangle with circles and numbers&#10;&#10;AI-generated content may be incorrect.">
             <a:extLst>
               <a:ext uri="{FF2B5EF4-FFF2-40B4-BE49-F238E27FC236}">
@@ -29599,76 +29840,6 @@
     <p:extLst>
       <p:ext uri="{BB962C8B-B14F-4D97-AF65-F5344CB8AC3E}">
         <p14:creationId xmlns:p14="http://schemas.microsoft.com/office/powerpoint/2010/main" val="2135268812"/>
-      </p:ext>
-    </p:extLst>
-  </p:cSld>
-  <p:clrMapOvr>
-    <a:masterClrMapping/>
-  </p:clrMapOvr>
-</p:sld>
-</file>
-
-<file path=ppt/slides/slide41.xml><?xml version="1.0" encoding="utf-8"?>
-<p:sld xmlns:a="http://schemas.openxmlformats.org/drawingml/2006/main" xmlns:r="http://schemas.openxmlformats.org/officeDocument/2006/relationships" xmlns:p="http://schemas.openxmlformats.org/presentationml/2006/main">
-  <p:cSld>
-    <p:spTree>
-      <p:nvGrpSpPr>
-        <p:cNvPr id="1" name="">
-          <a:extLst>
-            <a:ext uri="{FF2B5EF4-FFF2-40B4-BE49-F238E27FC236}">
-              <a16:creationId xmlns:a16="http://schemas.microsoft.com/office/drawing/2014/main" id="{0DA590B2-5171-C22A-49AD-529AC310A05E}"/>
-            </a:ext>
-          </a:extLst>
-        </p:cNvPr>
-        <p:cNvGrpSpPr/>
-        <p:nvPr/>
-      </p:nvGrpSpPr>
-      <p:grpSpPr>
-        <a:xfrm>
-          <a:off x="0" y="0"/>
-          <a:ext cx="0" cy="0"/>
-          <a:chOff x="0" y="0"/>
-          <a:chExt cx="0" cy="0"/>
-        </a:xfrm>
-      </p:grpSpPr>
-      <p:pic>
-        <p:nvPicPr>
-          <p:cNvPr id="5" name="Content Placeholder 4">
-            <a:extLst>
-              <a:ext uri="{FF2B5EF4-FFF2-40B4-BE49-F238E27FC236}">
-                <a16:creationId xmlns:a16="http://schemas.microsoft.com/office/drawing/2014/main" id="{9390A4A7-89F6-BC08-D5B5-164AF4CDEB28}"/>
-              </a:ext>
-            </a:extLst>
-          </p:cNvPr>
-          <p:cNvPicPr>
-            <a:picLocks noGrp="1" noChangeAspect="1"/>
-          </p:cNvPicPr>
-          <p:nvPr>
-            <p:ph idx="1"/>
-          </p:nvPr>
-        </p:nvPicPr>
-        <p:blipFill>
-          <a:blip r:embed="rId2">
-            <a:extLst>
-              <a:ext uri="{28A0092B-C50C-407E-A947-70E740481C1C}">
-                <a14:useLocalDpi xmlns:a14="http://schemas.microsoft.com/office/drawing/2010/main" val="0"/>
-              </a:ext>
-            </a:extLst>
-          </a:blip>
-          <a:srcRect/>
-          <a:stretch/>
-        </p:blipFill>
-        <p:spPr>
-          <a:xfrm>
-            <a:off x="2648737" y="881023"/>
-            <a:ext cx="6894525" cy="5095954"/>
-          </a:xfrm>
-        </p:spPr>
-      </p:pic>
-    </p:spTree>
-    <p:extLst>
-      <p:ext uri="{BB962C8B-B14F-4D97-AF65-F5344CB8AC3E}">
-        <p14:creationId xmlns:p14="http://schemas.microsoft.com/office/powerpoint/2010/main" val="658231613"/>
       </p:ext>
     </p:extLst>
   </p:cSld>
@@ -30883,6 +31054,14 @@
 <file path=ppt/slides/slide52.xml><?xml version="1.0" encoding="utf-8"?>
 <p:sld xmlns:a="http://schemas.openxmlformats.org/drawingml/2006/main" xmlns:r="http://schemas.openxmlformats.org/officeDocument/2006/relationships" xmlns:p="http://schemas.openxmlformats.org/presentationml/2006/main">
   <p:cSld>
+    <p:bg>
+      <p:bgPr>
+        <a:solidFill>
+          <a:schemeClr val="bg1"/>
+        </a:solidFill>
+        <a:effectLst/>
+      </p:bgPr>
+    </p:bg>
     <p:spTree>
       <p:nvGrpSpPr>
         <p:cNvPr id="1" name=""/>
@@ -30897,12 +31076,426 @@
           <a:chExt cx="0" cy="0"/>
         </a:xfrm>
       </p:grpSpPr>
+      <p:pic>
+        <p:nvPicPr>
+          <p:cNvPr id="4" name="Picture 3" descr="Red toy person in front of two lines of white figures">
+            <a:extLst>
+              <a:ext uri="{FF2B5EF4-FFF2-40B4-BE49-F238E27FC236}">
+                <a16:creationId xmlns:a16="http://schemas.microsoft.com/office/drawing/2014/main" id="{A36E903D-305B-B6C6-66E4-BF9107036717}"/>
+              </a:ext>
+            </a:extLst>
+          </p:cNvPr>
+          <p:cNvPicPr>
+            <a:picLocks noChangeAspect="1"/>
+          </p:cNvPicPr>
+          <p:nvPr/>
+        </p:nvPicPr>
+        <p:blipFill>
+          <a:blip r:embed="rId2"/>
+          <a:srcRect t="14201" r="1" b="1"/>
+          <a:stretch>
+            <a:fillRect/>
+          </a:stretch>
+        </p:blipFill>
+        <p:spPr>
+          <a:xfrm>
+            <a:off x="-3447" y="-1"/>
+            <a:ext cx="12195447" cy="6879745"/>
+          </a:xfrm>
+          <a:prstGeom prst="rect">
+            <a:avLst/>
+          </a:prstGeom>
+        </p:spPr>
+      </p:pic>
+      <p:sp>
+        <p:nvSpPr>
+          <p:cNvPr id="8" name="Rectangle 7">
+            <a:extLst>
+              <a:ext uri="{FF2B5EF4-FFF2-40B4-BE49-F238E27FC236}">
+                <a16:creationId xmlns:a16="http://schemas.microsoft.com/office/drawing/2014/main" id="{4D60F200-5EB0-B223-2439-C96C67F0FEE1}"/>
+              </a:ext>
+              <a:ext uri="{C183D7F6-B498-43B3-948B-1728B52AA6E4}">
+                <adec:decorative xmlns:adec="http://schemas.microsoft.com/office/drawing/2017/decorative" val="1"/>
+              </a:ext>
+            </a:extLst>
+          </p:cNvPr>
+          <p:cNvSpPr>
+            <a:spLocks noGrp="1" noRot="1" noChangeAspect="1" noMove="1" noResize="1" noEditPoints="1" noAdjustHandles="1" noChangeArrowheads="1" noChangeShapeType="1" noTextEdit="1"/>
+          </p:cNvSpPr>
+          <p:nvPr>
+            <p:extLst>
+              <p:ext uri="{386F3935-93C4-4BCD-93E2-E3B085C9AB24}">
+                <p16:designElem xmlns:p16="http://schemas.microsoft.com/office/powerpoint/2015/main" val="1"/>
+              </p:ext>
+            </p:extLst>
+          </p:nvPr>
+        </p:nvSpPr>
+        <p:spPr>
+          <a:xfrm rot="16200000">
+            <a:off x="4589414" y="-733991"/>
+            <a:ext cx="3020876" cy="12206596"/>
+          </a:xfrm>
+          <a:prstGeom prst="rect">
+            <a:avLst/>
+          </a:prstGeom>
+          <a:gradFill flip="none" rotWithShape="1">
+            <a:gsLst>
+              <a:gs pos="21000">
+                <a:srgbClr val="000000">
+                  <a:alpha val="62000"/>
+                </a:srgbClr>
+              </a:gs>
+              <a:gs pos="100000">
+                <a:srgbClr val="000000">
+                  <a:alpha val="0"/>
+                </a:srgbClr>
+              </a:gs>
+            </a:gsLst>
+            <a:lin ang="0" scaled="0"/>
+            <a:tileRect/>
+          </a:gradFill>
+          <a:ln>
+            <a:noFill/>
+          </a:ln>
+        </p:spPr>
+        <p:style>
+          <a:lnRef idx="2">
+            <a:schemeClr val="accent1">
+              <a:shade val="50000"/>
+            </a:schemeClr>
+          </a:lnRef>
+          <a:fillRef idx="1">
+            <a:schemeClr val="accent1"/>
+          </a:fillRef>
+          <a:effectRef idx="0">
+            <a:schemeClr val="accent1"/>
+          </a:effectRef>
+          <a:fontRef idx="minor">
+            <a:schemeClr val="lt1"/>
+          </a:fontRef>
+        </p:style>
+        <p:txBody>
+          <a:bodyPr rtlCol="0" anchor="ctr"/>
+          <a:lstStyle/>
+          <a:p>
+            <a:pPr algn="ctr"/>
+            <a:endParaRPr lang="en-US"/>
+          </a:p>
+        </p:txBody>
+      </p:sp>
+      <p:sp>
+        <p:nvSpPr>
+          <p:cNvPr id="10" name="Rectangle 9">
+            <a:extLst>
+              <a:ext uri="{FF2B5EF4-FFF2-40B4-BE49-F238E27FC236}">
+                <a16:creationId xmlns:a16="http://schemas.microsoft.com/office/drawing/2014/main" id="{A6567EA8-C72D-4B9B-D23F-6B2E9F9C9F47}"/>
+              </a:ext>
+              <a:ext uri="{C183D7F6-B498-43B3-948B-1728B52AA6E4}">
+                <adec:decorative xmlns:adec="http://schemas.microsoft.com/office/drawing/2017/decorative" val="1"/>
+              </a:ext>
+            </a:extLst>
+          </p:cNvPr>
+          <p:cNvSpPr>
+            <a:spLocks noGrp="1" noRot="1" noChangeAspect="1" noMove="1" noResize="1" noEditPoints="1" noAdjustHandles="1" noChangeArrowheads="1" noChangeShapeType="1" noTextEdit="1"/>
+          </p:cNvSpPr>
+          <p:nvPr>
+            <p:extLst>
+              <p:ext uri="{386F3935-93C4-4BCD-93E2-E3B085C9AB24}">
+                <p16:designElem xmlns:p16="http://schemas.microsoft.com/office/powerpoint/2015/main" val="1"/>
+              </p:ext>
+            </p:extLst>
+          </p:nvPr>
+        </p:nvSpPr>
+        <p:spPr>
+          <a:xfrm rot="10800000">
+            <a:off x="-3446" y="0"/>
+            <a:ext cx="2843402" cy="6879745"/>
+          </a:xfrm>
+          <a:prstGeom prst="rect">
+            <a:avLst/>
+          </a:prstGeom>
+          <a:gradFill flip="none" rotWithShape="1">
+            <a:gsLst>
+              <a:gs pos="5000">
+                <a:schemeClr val="accent2"/>
+              </a:gs>
+              <a:gs pos="49000">
+                <a:schemeClr val="accent5">
+                  <a:lumMod val="60000"/>
+                  <a:lumOff val="40000"/>
+                  <a:alpha val="0"/>
+                </a:schemeClr>
+              </a:gs>
+            </a:gsLst>
+            <a:lin ang="9600000" scaled="0"/>
+            <a:tileRect/>
+          </a:gradFill>
+          <a:ln>
+            <a:noFill/>
+          </a:ln>
+        </p:spPr>
+        <p:style>
+          <a:lnRef idx="2">
+            <a:schemeClr val="accent1">
+              <a:shade val="50000"/>
+            </a:schemeClr>
+          </a:lnRef>
+          <a:fillRef idx="1">
+            <a:schemeClr val="accent1"/>
+          </a:fillRef>
+          <a:effectRef idx="0">
+            <a:schemeClr val="accent1"/>
+          </a:effectRef>
+          <a:fontRef idx="minor">
+            <a:schemeClr val="lt1"/>
+          </a:fontRef>
+        </p:style>
+        <p:txBody>
+          <a:bodyPr rtlCol="0" anchor="ctr"/>
+          <a:lstStyle/>
+          <a:p>
+            <a:pPr algn="ctr"/>
+            <a:endParaRPr lang="en-US"/>
+          </a:p>
+        </p:txBody>
+      </p:sp>
+      <p:sp>
+        <p:nvSpPr>
+          <p:cNvPr id="12" name="Rectangle 11">
+            <a:extLst>
+              <a:ext uri="{FF2B5EF4-FFF2-40B4-BE49-F238E27FC236}">
+                <a16:creationId xmlns:a16="http://schemas.microsoft.com/office/drawing/2014/main" id="{FEFBFA78-9360-1E01-5448-6D5AE0A32601}"/>
+              </a:ext>
+              <a:ext uri="{C183D7F6-B498-43B3-948B-1728B52AA6E4}">
+                <adec:decorative xmlns:adec="http://schemas.microsoft.com/office/drawing/2017/decorative" val="1"/>
+              </a:ext>
+            </a:extLst>
+          </p:cNvPr>
+          <p:cNvSpPr>
+            <a:spLocks noGrp="1" noRot="1" noChangeAspect="1" noMove="1" noResize="1" noEditPoints="1" noAdjustHandles="1" noChangeArrowheads="1" noChangeShapeType="1" noTextEdit="1"/>
+          </p:cNvSpPr>
+          <p:nvPr>
+            <p:extLst>
+              <p:ext uri="{386F3935-93C4-4BCD-93E2-E3B085C9AB24}">
+                <p16:designElem xmlns:p16="http://schemas.microsoft.com/office/powerpoint/2015/main" val="1"/>
+              </p:ext>
+            </p:extLst>
+          </p:nvPr>
+        </p:nvSpPr>
+        <p:spPr>
+          <a:xfrm rot="10800000">
+            <a:off x="9038704" y="21736"/>
+            <a:ext cx="3152862" cy="6858008"/>
+          </a:xfrm>
+          <a:prstGeom prst="rect">
+            <a:avLst/>
+          </a:prstGeom>
+          <a:gradFill flip="none" rotWithShape="1">
+            <a:gsLst>
+              <a:gs pos="5000">
+                <a:schemeClr val="accent5">
+                  <a:alpha val="48000"/>
+                </a:schemeClr>
+              </a:gs>
+              <a:gs pos="42000">
+                <a:schemeClr val="accent5">
+                  <a:alpha val="0"/>
+                </a:schemeClr>
+              </a:gs>
+            </a:gsLst>
+            <a:lin ang="1800000" scaled="0"/>
+            <a:tileRect/>
+          </a:gradFill>
+          <a:ln>
+            <a:noFill/>
+          </a:ln>
+        </p:spPr>
+        <p:style>
+          <a:lnRef idx="2">
+            <a:schemeClr val="accent1">
+              <a:shade val="50000"/>
+            </a:schemeClr>
+          </a:lnRef>
+          <a:fillRef idx="1">
+            <a:schemeClr val="accent1"/>
+          </a:fillRef>
+          <a:effectRef idx="0">
+            <a:schemeClr val="accent1"/>
+          </a:effectRef>
+          <a:fontRef idx="minor">
+            <a:schemeClr val="lt1"/>
+          </a:fontRef>
+        </p:style>
+        <p:txBody>
+          <a:bodyPr rtlCol="0" anchor="ctr"/>
+          <a:lstStyle/>
+          <a:p>
+            <a:pPr algn="ctr"/>
+            <a:endParaRPr lang="en-US"/>
+          </a:p>
+        </p:txBody>
+      </p:sp>
+      <p:sp>
+        <p:nvSpPr>
+          <p:cNvPr id="14" name="Rectangle 13">
+            <a:extLst>
+              <a:ext uri="{FF2B5EF4-FFF2-40B4-BE49-F238E27FC236}">
+                <a16:creationId xmlns:a16="http://schemas.microsoft.com/office/drawing/2014/main" id="{1740453C-744F-DB3A-47EC-15EACE1DC117}"/>
+              </a:ext>
+              <a:ext uri="{C183D7F6-B498-43B3-948B-1728B52AA6E4}">
+                <adec:decorative xmlns:adec="http://schemas.microsoft.com/office/drawing/2017/decorative" val="1"/>
+              </a:ext>
+            </a:extLst>
+          </p:cNvPr>
+          <p:cNvSpPr>
+            <a:spLocks noGrp="1" noRot="1" noChangeAspect="1" noMove="1" noResize="1" noEditPoints="1" noAdjustHandles="1" noChangeArrowheads="1" noChangeShapeType="1" noTextEdit="1"/>
+          </p:cNvSpPr>
+          <p:nvPr>
+            <p:extLst>
+              <p:ext uri="{386F3935-93C4-4BCD-93E2-E3B085C9AB24}">
+                <p16:designElem xmlns:p16="http://schemas.microsoft.com/office/powerpoint/2015/main" val="1"/>
+              </p:ext>
+            </p:extLst>
+          </p:nvPr>
+        </p:nvSpPr>
+        <p:spPr>
+          <a:xfrm rot="10800000">
+            <a:off x="-3447" y="5288433"/>
+            <a:ext cx="12199706" cy="1591311"/>
+          </a:xfrm>
+          <a:prstGeom prst="rect">
+            <a:avLst/>
+          </a:prstGeom>
+          <a:gradFill flip="none" rotWithShape="1">
+            <a:gsLst>
+              <a:gs pos="0">
+                <a:schemeClr val="accent2"/>
+              </a:gs>
+              <a:gs pos="49000">
+                <a:schemeClr val="accent2">
+                  <a:alpha val="0"/>
+                </a:schemeClr>
+              </a:gs>
+            </a:gsLst>
+            <a:lin ang="5880000" scaled="0"/>
+            <a:tileRect/>
+          </a:gradFill>
+          <a:ln w="12700" cap="flat" cmpd="sng" algn="ctr">
+            <a:noFill/>
+            <a:prstDash val="solid"/>
+            <a:miter lim="800000"/>
+          </a:ln>
+          <a:effectLst/>
+        </p:spPr>
+        <p:style>
+          <a:lnRef idx="2">
+            <a:schemeClr val="accent1">
+              <a:shade val="50000"/>
+            </a:schemeClr>
+          </a:lnRef>
+          <a:fillRef idx="1">
+            <a:schemeClr val="accent1"/>
+          </a:fillRef>
+          <a:effectRef idx="0">
+            <a:schemeClr val="accent1"/>
+          </a:effectRef>
+          <a:fontRef idx="minor">
+            <a:schemeClr val="lt1"/>
+          </a:fontRef>
+        </p:style>
+        <p:txBody>
+          <a:bodyPr rtlCol="0" anchor="ctr"/>
+          <a:lstStyle/>
+          <a:p>
+            <a:pPr algn="r"/>
+            <a:endParaRPr lang="en-US"/>
+          </a:p>
+        </p:txBody>
+      </p:sp>
+      <p:sp>
+        <p:nvSpPr>
+          <p:cNvPr id="16" name="Rectangle 15">
+            <a:extLst>
+              <a:ext uri="{FF2B5EF4-FFF2-40B4-BE49-F238E27FC236}">
+                <a16:creationId xmlns:a16="http://schemas.microsoft.com/office/drawing/2014/main" id="{B6924B03-77BD-EAE3-2854-43363FF8E6BB}"/>
+              </a:ext>
+              <a:ext uri="{C183D7F6-B498-43B3-948B-1728B52AA6E4}">
+                <adec:decorative xmlns:adec="http://schemas.microsoft.com/office/drawing/2017/decorative" val="1"/>
+              </a:ext>
+            </a:extLst>
+          </p:cNvPr>
+          <p:cNvSpPr>
+            <a:spLocks noGrp="1" noRot="1" noChangeAspect="1" noMove="1" noResize="1" noEditPoints="1" noAdjustHandles="1" noChangeArrowheads="1" noChangeShapeType="1" noTextEdit="1"/>
+          </p:cNvSpPr>
+          <p:nvPr>
+            <p:extLst>
+              <p:ext uri="{386F3935-93C4-4BCD-93E2-E3B085C9AB24}">
+                <p16:designElem xmlns:p16="http://schemas.microsoft.com/office/powerpoint/2015/main" val="1"/>
+              </p:ext>
+            </p:extLst>
+          </p:nvPr>
+        </p:nvSpPr>
+        <p:spPr>
+          <a:xfrm rot="5400000">
+            <a:off x="784596" y="2224929"/>
+            <a:ext cx="3866773" cy="5442859"/>
+          </a:xfrm>
+          <a:prstGeom prst="rect">
+            <a:avLst/>
+          </a:prstGeom>
+          <a:gradFill flip="none" rotWithShape="1">
+            <a:gsLst>
+              <a:gs pos="0">
+                <a:schemeClr val="accent5"/>
+              </a:gs>
+              <a:gs pos="54000">
+                <a:schemeClr val="accent5">
+                  <a:lumMod val="60000"/>
+                  <a:lumOff val="40000"/>
+                  <a:alpha val="0"/>
+                </a:schemeClr>
+              </a:gs>
+            </a:gsLst>
+            <a:path path="circle">
+              <a:fillToRect l="100000" t="100000"/>
+            </a:path>
+            <a:tileRect r="-100000" b="-100000"/>
+          </a:gradFill>
+          <a:ln>
+            <a:noFill/>
+          </a:ln>
+        </p:spPr>
+        <p:style>
+          <a:lnRef idx="2">
+            <a:schemeClr val="accent1">
+              <a:shade val="50000"/>
+            </a:schemeClr>
+          </a:lnRef>
+          <a:fillRef idx="1">
+            <a:schemeClr val="accent1"/>
+          </a:fillRef>
+          <a:effectRef idx="0">
+            <a:schemeClr val="accent1"/>
+          </a:effectRef>
+          <a:fontRef idx="minor">
+            <a:schemeClr val="lt1"/>
+          </a:fontRef>
+        </p:style>
+        <p:txBody>
+          <a:bodyPr rtlCol="0" anchor="ctr"/>
+          <a:lstStyle/>
+          <a:p>
+            <a:pPr algn="ctr"/>
+            <a:endParaRPr lang="en-US"/>
+          </a:p>
+        </p:txBody>
+      </p:sp>
       <p:sp>
         <p:nvSpPr>
           <p:cNvPr id="2" name="Title 1">
             <a:extLst>
               <a:ext uri="{FF2B5EF4-FFF2-40B4-BE49-F238E27FC236}">
-                <a16:creationId xmlns:a16="http://schemas.microsoft.com/office/drawing/2014/main" id="{FCD69641-A7F6-17B4-E83E-F52115E98D57}"/>
+                <a16:creationId xmlns:a16="http://schemas.microsoft.com/office/drawing/2014/main" id="{023C9642-64EB-04D7-5D3D-CD9242C3E443}"/>
               </a:ext>
             </a:extLst>
           </p:cNvPr>
@@ -30913,24 +31506,411 @@
             <p:ph type="title"/>
           </p:nvPr>
         </p:nvSpPr>
-        <p:spPr/>
+        <p:spPr>
+          <a:xfrm>
+            <a:off x="859028" y="4121944"/>
+            <a:ext cx="7927785" cy="1620665"/>
+          </a:xfrm>
+        </p:spPr>
         <p:txBody>
-          <a:bodyPr/>
+          <a:bodyPr vert="horz" lIns="91440" tIns="45720" rIns="91440" bIns="45720" rtlCol="0" anchor="b">
+            <a:normAutofit/>
+          </a:bodyPr>
           <a:lstStyle/>
           <a:p>
             <a:r>
-              <a:rPr lang="en-US" dirty="0"/>
+              <a:rPr lang="en-US" sz="4000">
+                <a:solidFill>
+                  <a:srgbClr val="FFFFFF"/>
+                </a:solidFill>
+              </a:rPr>
               <a:t>Priority queue</a:t>
             </a:r>
+          </a:p>
+        </p:txBody>
+      </p:sp>
+    </p:spTree>
+    <p:extLst>
+      <p:ext uri="{BB962C8B-B14F-4D97-AF65-F5344CB8AC3E}">
+        <p14:creationId xmlns:p14="http://schemas.microsoft.com/office/powerpoint/2010/main" val="659289454"/>
+      </p:ext>
+    </p:extLst>
+  </p:cSld>
+  <p:clrMapOvr>
+    <a:masterClrMapping/>
+  </p:clrMapOvr>
+</p:sld>
+</file>
+
+<file path=ppt/slides/slide53.xml><?xml version="1.0" encoding="utf-8"?>
+<p:sld xmlns:a="http://schemas.openxmlformats.org/drawingml/2006/main" xmlns:r="http://schemas.openxmlformats.org/officeDocument/2006/relationships" xmlns:p="http://schemas.openxmlformats.org/presentationml/2006/main">
+  <p:cSld>
+    <p:spTree>
+      <p:nvGrpSpPr>
+        <p:cNvPr id="1" name=""/>
+        <p:cNvGrpSpPr/>
+        <p:nvPr/>
+      </p:nvGrpSpPr>
+      <p:grpSpPr>
+        <a:xfrm>
+          <a:off x="0" y="0"/>
+          <a:ext cx="0" cy="0"/>
+          <a:chOff x="0" y="0"/>
+          <a:chExt cx="0" cy="0"/>
+        </a:xfrm>
+      </p:grpSpPr>
+      <p:pic>
+        <p:nvPicPr>
+          <p:cNvPr id="12" name="Content Placeholder 11" descr="A diagram of a number&#10;&#10;AI-generated content may be incorrect.">
+            <a:extLst>
+              <a:ext uri="{FF2B5EF4-FFF2-40B4-BE49-F238E27FC236}">
+                <a16:creationId xmlns:a16="http://schemas.microsoft.com/office/drawing/2014/main" id="{B58FD086-7839-8FBA-8E51-1FD13D01A632}"/>
+              </a:ext>
+            </a:extLst>
+          </p:cNvPr>
+          <p:cNvPicPr>
+            <a:picLocks noGrp="1" noChangeAspect="1"/>
+          </p:cNvPicPr>
+          <p:nvPr>
+            <p:ph idx="1"/>
+          </p:nvPr>
+        </p:nvPicPr>
+        <p:blipFill>
+          <a:blip r:embed="rId2">
+            <a:extLst>
+              <a:ext uri="{28A0092B-C50C-407E-A947-70E740481C1C}">
+                <a14:useLocalDpi xmlns:a14="http://schemas.microsoft.com/office/drawing/2010/main" val="0"/>
+              </a:ext>
+            </a:extLst>
+          </a:blip>
+          <a:stretch>
+            <a:fillRect/>
+          </a:stretch>
+        </p:blipFill>
+        <p:spPr>
+          <a:xfrm>
+            <a:off x="96716" y="1108710"/>
+            <a:ext cx="12095284" cy="3780524"/>
+          </a:xfrm>
+        </p:spPr>
+      </p:pic>
+    </p:spTree>
+    <p:extLst>
+      <p:ext uri="{BB962C8B-B14F-4D97-AF65-F5344CB8AC3E}">
+        <p14:creationId xmlns:p14="http://schemas.microsoft.com/office/powerpoint/2010/main" val="297016650"/>
+      </p:ext>
+    </p:extLst>
+  </p:cSld>
+  <p:clrMapOvr>
+    <a:masterClrMapping/>
+  </p:clrMapOvr>
+</p:sld>
+</file>
+
+<file path=ppt/slides/slide54.xml><?xml version="1.0" encoding="utf-8"?>
+<p:sld xmlns:a="http://schemas.openxmlformats.org/drawingml/2006/main" xmlns:r="http://schemas.openxmlformats.org/officeDocument/2006/relationships" xmlns:p="http://schemas.openxmlformats.org/presentationml/2006/main">
+  <p:cSld>
+    <p:spTree>
+      <p:nvGrpSpPr>
+        <p:cNvPr id="1" name=""/>
+        <p:cNvGrpSpPr/>
+        <p:nvPr/>
+      </p:nvGrpSpPr>
+      <p:grpSpPr>
+        <a:xfrm>
+          <a:off x="0" y="0"/>
+          <a:ext cx="0" cy="0"/>
+          <a:chOff x="0" y="0"/>
+          <a:chExt cx="0" cy="0"/>
+        </a:xfrm>
+      </p:grpSpPr>
+      <p:pic>
+        <p:nvPicPr>
+          <p:cNvPr id="5" name="Content Placeholder 4" descr="A diagram of numbers and circles&#10;&#10;AI-generated content may be incorrect.">
+            <a:extLst>
+              <a:ext uri="{FF2B5EF4-FFF2-40B4-BE49-F238E27FC236}">
+                <a16:creationId xmlns:a16="http://schemas.microsoft.com/office/drawing/2014/main" id="{2579E46E-9337-CB32-9C88-000B70F63BDE}"/>
+              </a:ext>
+            </a:extLst>
+          </p:cNvPr>
+          <p:cNvPicPr>
+            <a:picLocks noGrp="1" noChangeAspect="1"/>
+          </p:cNvPicPr>
+          <p:nvPr>
+            <p:ph idx="1"/>
+          </p:nvPr>
+        </p:nvPicPr>
+        <p:blipFill>
+          <a:blip r:embed="rId2">
+            <a:extLst>
+              <a:ext uri="{28A0092B-C50C-407E-A947-70E740481C1C}">
+                <a14:useLocalDpi xmlns:a14="http://schemas.microsoft.com/office/drawing/2010/main" val="0"/>
+              </a:ext>
+            </a:extLst>
+          </a:blip>
+          <a:stretch>
+            <a:fillRect/>
+          </a:stretch>
+        </p:blipFill>
+        <p:spPr>
+          <a:xfrm>
+            <a:off x="2964043" y="768357"/>
+            <a:ext cx="6263914" cy="5321285"/>
+          </a:xfrm>
+        </p:spPr>
+      </p:pic>
+    </p:spTree>
+    <p:extLst>
+      <p:ext uri="{BB962C8B-B14F-4D97-AF65-F5344CB8AC3E}">
+        <p14:creationId xmlns:p14="http://schemas.microsoft.com/office/powerpoint/2010/main" val="3755166449"/>
+      </p:ext>
+    </p:extLst>
+  </p:cSld>
+  <p:clrMapOvr>
+    <a:masterClrMapping/>
+  </p:clrMapOvr>
+</p:sld>
+</file>
+
+<file path=ppt/slides/slide55.xml><?xml version="1.0" encoding="utf-8"?>
+<p:sld xmlns:a="http://schemas.openxmlformats.org/drawingml/2006/main" xmlns:r="http://schemas.openxmlformats.org/officeDocument/2006/relationships" xmlns:p="http://schemas.openxmlformats.org/presentationml/2006/main">
+  <p:cSld>
+    <p:spTree>
+      <p:nvGrpSpPr>
+        <p:cNvPr id="1" name="">
+          <a:extLst>
+            <a:ext uri="{FF2B5EF4-FFF2-40B4-BE49-F238E27FC236}">
+              <a16:creationId xmlns:a16="http://schemas.microsoft.com/office/drawing/2014/main" id="{0767D704-9E14-6006-E88D-3CC3938F53F3}"/>
+            </a:ext>
+          </a:extLst>
+        </p:cNvPr>
+        <p:cNvGrpSpPr/>
+        <p:nvPr/>
+      </p:nvGrpSpPr>
+      <p:grpSpPr>
+        <a:xfrm>
+          <a:off x="0" y="0"/>
+          <a:ext cx="0" cy="0"/>
+          <a:chOff x="0" y="0"/>
+          <a:chExt cx="0" cy="0"/>
+        </a:xfrm>
+      </p:grpSpPr>
+      <p:pic>
+        <p:nvPicPr>
+          <p:cNvPr id="5" name="Content Placeholder 4">
+            <a:extLst>
+              <a:ext uri="{FF2B5EF4-FFF2-40B4-BE49-F238E27FC236}">
+                <a16:creationId xmlns:a16="http://schemas.microsoft.com/office/drawing/2014/main" id="{9ABFC7A2-50A6-1B14-9F3D-64CFC905AA1F}"/>
+              </a:ext>
+            </a:extLst>
+          </p:cNvPr>
+          <p:cNvPicPr>
+            <a:picLocks noGrp="1" noChangeAspect="1"/>
+          </p:cNvPicPr>
+          <p:nvPr>
+            <p:ph idx="1"/>
+          </p:nvPr>
+        </p:nvPicPr>
+        <p:blipFill>
+          <a:blip r:embed="rId2">
+            <a:extLst>
+              <a:ext uri="{28A0092B-C50C-407E-A947-70E740481C1C}">
+                <a14:useLocalDpi xmlns:a14="http://schemas.microsoft.com/office/drawing/2010/main" val="0"/>
+              </a:ext>
+            </a:extLst>
+          </a:blip>
+          <a:srcRect/>
+          <a:stretch/>
+        </p:blipFill>
+        <p:spPr>
+          <a:xfrm>
+            <a:off x="2964043" y="521338"/>
+            <a:ext cx="6263914" cy="5815323"/>
+          </a:xfrm>
+        </p:spPr>
+      </p:pic>
+    </p:spTree>
+    <p:extLst>
+      <p:ext uri="{BB962C8B-B14F-4D97-AF65-F5344CB8AC3E}">
+        <p14:creationId xmlns:p14="http://schemas.microsoft.com/office/powerpoint/2010/main" val="2063630400"/>
+      </p:ext>
+    </p:extLst>
+  </p:cSld>
+  <p:clrMapOvr>
+    <a:masterClrMapping/>
+  </p:clrMapOvr>
+</p:sld>
+</file>
+
+<file path=ppt/slides/slide56.xml><?xml version="1.0" encoding="utf-8"?>
+<p:sld xmlns:a="http://schemas.openxmlformats.org/drawingml/2006/main" xmlns:r="http://schemas.openxmlformats.org/officeDocument/2006/relationships" xmlns:p="http://schemas.openxmlformats.org/presentationml/2006/main">
+  <p:cSld>
+    <p:bg>
+      <p:bgPr>
+        <a:solidFill>
+          <a:schemeClr val="bg1"/>
+        </a:solidFill>
+        <a:effectLst/>
+      </p:bgPr>
+    </p:bg>
+    <p:spTree>
+      <p:nvGrpSpPr>
+        <p:cNvPr id="1" name=""/>
+        <p:cNvGrpSpPr/>
+        <p:nvPr/>
+      </p:nvGrpSpPr>
+      <p:grpSpPr>
+        <a:xfrm>
+          <a:off x="0" y="0"/>
+          <a:ext cx="0" cy="0"/>
+          <a:chOff x="0" y="0"/>
+          <a:chExt cx="0" cy="0"/>
+        </a:xfrm>
+      </p:grpSpPr>
+      <p:sp useBgFill="1">
+        <p:nvSpPr>
+          <p:cNvPr id="37" name="Rectangle 36">
+            <a:extLst>
+              <a:ext uri="{FF2B5EF4-FFF2-40B4-BE49-F238E27FC236}">
+                <a16:creationId xmlns:a16="http://schemas.microsoft.com/office/drawing/2014/main" id="{1ACA2EA0-FFD3-42EC-9406-B595015ED96E}"/>
+              </a:ext>
+              <a:ext uri="{C183D7F6-B498-43B3-948B-1728B52AA6E4}">
+                <adec:decorative xmlns:adec="http://schemas.microsoft.com/office/drawing/2017/decorative" val="1"/>
+              </a:ext>
+            </a:extLst>
+          </p:cNvPr>
+          <p:cNvSpPr>
+            <a:spLocks noGrp="1" noRot="1" noChangeAspect="1" noMove="1" noResize="1" noEditPoints="1" noAdjustHandles="1" noChangeArrowheads="1" noChangeShapeType="1" noTextEdit="1"/>
+          </p:cNvSpPr>
+          <p:nvPr>
+            <p:extLst>
+              <p:ext uri="{386F3935-93C4-4BCD-93E2-E3B085C9AB24}">
+                <p16:designElem xmlns:p16="http://schemas.microsoft.com/office/powerpoint/2015/main" val="1"/>
+              </p:ext>
+            </p:extLst>
+          </p:nvPr>
+        </p:nvSpPr>
+        <p:spPr>
+          <a:xfrm>
+            <a:off x="0" y="0"/>
+            <a:ext cx="12192000" cy="6858000"/>
+          </a:xfrm>
+          <a:prstGeom prst="rect">
+            <a:avLst/>
+          </a:prstGeom>
+          <a:ln>
+            <a:noFill/>
+          </a:ln>
+        </p:spPr>
+        <p:style>
+          <a:lnRef idx="2">
+            <a:schemeClr val="accent1">
+              <a:shade val="50000"/>
+            </a:schemeClr>
+          </a:lnRef>
+          <a:fillRef idx="1">
+            <a:schemeClr val="accent1"/>
+          </a:fillRef>
+          <a:effectRef idx="0">
+            <a:schemeClr val="accent1"/>
+          </a:effectRef>
+          <a:fontRef idx="minor">
+            <a:schemeClr val="lt1"/>
+          </a:fontRef>
+        </p:style>
+        <p:txBody>
+          <a:bodyPr rtlCol="0" anchor="ctr"/>
+          <a:lstStyle/>
+          <a:p>
+            <a:pPr algn="ctr"/>
+            <a:endParaRPr lang="en-US"/>
+          </a:p>
+        </p:txBody>
+      </p:sp>
+      <p:sp useBgFill="1">
+        <p:nvSpPr>
+          <p:cNvPr id="39" name="Rectangle 38">
+            <a:extLst>
+              <a:ext uri="{FF2B5EF4-FFF2-40B4-BE49-F238E27FC236}">
+                <a16:creationId xmlns:a16="http://schemas.microsoft.com/office/drawing/2014/main" id="{D5288BCE-665C-472A-8C43-664BCFA31E43}"/>
+              </a:ext>
+              <a:ext uri="{C183D7F6-B498-43B3-948B-1728B52AA6E4}">
+                <adec:decorative xmlns:adec="http://schemas.microsoft.com/office/drawing/2017/decorative" val="1"/>
+              </a:ext>
+            </a:extLst>
+          </p:cNvPr>
+          <p:cNvSpPr>
+            <a:spLocks noGrp="1" noRot="1" noChangeAspect="1" noMove="1" noResize="1" noEditPoints="1" noAdjustHandles="1" noChangeArrowheads="1" noChangeShapeType="1" noTextEdit="1"/>
+          </p:cNvSpPr>
+          <p:nvPr>
+            <p:extLst>
+              <p:ext uri="{386F3935-93C4-4BCD-93E2-E3B085C9AB24}">
+                <p16:designElem xmlns:p16="http://schemas.microsoft.com/office/powerpoint/2015/main" val="1"/>
+              </p:ext>
+            </p:extLst>
+          </p:nvPr>
+        </p:nvSpPr>
+        <p:spPr>
+          <a:xfrm>
+            <a:off x="1528762" y="1247775"/>
+            <a:ext cx="9144000" cy="3007447"/>
+          </a:xfrm>
+          <a:prstGeom prst="rect">
+            <a:avLst/>
+          </a:prstGeom>
+          <a:solidFill>
+            <a:schemeClr val="bg1"/>
+          </a:solidFill>
+          <a:ln w="12700">
+            <a:solidFill>
+              <a:srgbClr val="E1E1E1"/>
+            </a:solidFill>
+          </a:ln>
+          <a:effectLst>
+            <a:outerShdw blurRad="50800" dist="38100" dir="2700000" algn="tl" rotWithShape="0">
+              <a:schemeClr val="bg1">
+                <a:lumMod val="85000"/>
+                <a:alpha val="50000"/>
+              </a:schemeClr>
+            </a:outerShdw>
+          </a:effectLst>
+        </p:spPr>
+        <p:style>
+          <a:lnRef idx="2">
+            <a:schemeClr val="accent1">
+              <a:shade val="50000"/>
+            </a:schemeClr>
+          </a:lnRef>
+          <a:fillRef idx="1">
+            <a:schemeClr val="accent1"/>
+          </a:fillRef>
+          <a:effectRef idx="0">
+            <a:schemeClr val="accent1"/>
+          </a:effectRef>
+          <a:fontRef idx="minor">
+            <a:schemeClr val="lt1"/>
+          </a:fontRef>
+        </p:style>
+        <p:txBody>
+          <a:bodyPr rtlCol="0" anchor="ctr"/>
+          <a:lstStyle/>
+          <a:p>
+            <a:pPr algn="ctr"/>
+            <a:endParaRPr lang="en-US">
+              <a:solidFill>
+                <a:prstClr val="white"/>
+              </a:solidFill>
+              <a:latin typeface="Calibri" panose="020F0502020204030204"/>
+            </a:endParaRPr>
           </a:p>
         </p:txBody>
       </p:sp>
       <p:sp>
         <p:nvSpPr>
-          <p:cNvPr id="3" name="Content Placeholder 2">
+          <p:cNvPr id="2" name="Title 1">
             <a:extLst>
               <a:ext uri="{FF2B5EF4-FFF2-40B4-BE49-F238E27FC236}">
-                <a16:creationId xmlns:a16="http://schemas.microsoft.com/office/drawing/2014/main" id="{AB95E45E-6A9C-6E36-C818-539ED98870C4}"/>
+                <a16:creationId xmlns:a16="http://schemas.microsoft.com/office/drawing/2014/main" id="{0834495A-C6A5-82DE-DE89-9507871B4EBB}"/>
               </a:ext>
             </a:extLst>
           </p:cNvPr>
@@ -30938,14 +31918,97 @@
             <a:spLocks noGrp="1"/>
           </p:cNvSpPr>
           <p:nvPr>
-            <p:ph idx="1"/>
+            <p:ph type="title"/>
           </p:nvPr>
         </p:nvSpPr>
-        <p:spPr/>
+        <p:spPr>
+          <a:xfrm>
+            <a:off x="1804988" y="1442172"/>
+            <a:ext cx="8582025" cy="2177328"/>
+          </a:xfrm>
+        </p:spPr>
         <p:txBody>
-          <a:bodyPr/>
+          <a:bodyPr vert="horz" lIns="91440" tIns="45720" rIns="91440" bIns="45720" rtlCol="0" anchor="ctr">
+            <a:normAutofit/>
+          </a:bodyPr>
           <a:lstStyle/>
           <a:p>
+            <a:pPr algn="ctr"/>
+            <a:r>
+              <a:rPr lang="en-US" sz="6600" kern="1200" dirty="0">
+                <a:solidFill>
+                  <a:schemeClr val="tx1"/>
+                </a:solidFill>
+                <a:latin typeface="+mj-lt"/>
+                <a:ea typeface="+mj-ea"/>
+                <a:cs typeface="+mj-cs"/>
+              </a:rPr>
+              <a:t>Removing the largest element</a:t>
+            </a:r>
+          </a:p>
+        </p:txBody>
+      </p:sp>
+      <p:sp>
+        <p:nvSpPr>
+          <p:cNvPr id="41" name="Rectangle: Rounded Corners 40">
+            <a:extLst>
+              <a:ext uri="{FF2B5EF4-FFF2-40B4-BE49-F238E27FC236}">
+                <a16:creationId xmlns:a16="http://schemas.microsoft.com/office/drawing/2014/main" id="{46C57131-53A7-4C1A-BEA8-25F06A06AD29}"/>
+              </a:ext>
+              <a:ext uri="{C183D7F6-B498-43B3-948B-1728B52AA6E4}">
+                <adec:decorative xmlns:adec="http://schemas.microsoft.com/office/drawing/2017/decorative" val="1"/>
+              </a:ext>
+            </a:extLst>
+          </p:cNvPr>
+          <p:cNvSpPr>
+            <a:spLocks noGrp="1" noRot="1" noChangeAspect="1" noMove="1" noResize="1" noEditPoints="1" noAdjustHandles="1" noChangeArrowheads="1" noChangeShapeType="1" noTextEdit="1"/>
+          </p:cNvSpPr>
+          <p:nvPr>
+            <p:extLst>
+              <p:ext uri="{386F3935-93C4-4BCD-93E2-E3B085C9AB24}">
+                <p16:designElem xmlns:p16="http://schemas.microsoft.com/office/powerpoint/2015/main" val="1"/>
+              </p:ext>
+            </p:extLst>
+          </p:nvPr>
+        </p:nvSpPr>
+        <p:spPr>
+          <a:xfrm>
+            <a:off x="2487872" y="3912322"/>
+            <a:ext cx="7225780" cy="685800"/>
+          </a:xfrm>
+          <a:prstGeom prst="roundRect">
+            <a:avLst>
+              <a:gd name="adj" fmla="val 0"/>
+            </a:avLst>
+          </a:prstGeom>
+          <a:solidFill>
+            <a:schemeClr val="accent2"/>
+          </a:solidFill>
+          <a:ln>
+            <a:noFill/>
+          </a:ln>
+        </p:spPr>
+        <p:style>
+          <a:lnRef idx="2">
+            <a:schemeClr val="accent1">
+              <a:shade val="50000"/>
+            </a:schemeClr>
+          </a:lnRef>
+          <a:fillRef idx="1">
+            <a:schemeClr val="accent1"/>
+          </a:fillRef>
+          <a:effectRef idx="0">
+            <a:schemeClr val="accent1"/>
+          </a:effectRef>
+          <a:fontRef idx="minor">
+            <a:schemeClr val="lt1"/>
+          </a:fontRef>
+        </p:style>
+        <p:txBody>
+          <a:bodyPr rtlCol="0" anchor="ctr"/>
+          <a:lstStyle/>
+          <a:p>
+            <a:pPr algn="ctr"/>
             <a:endParaRPr lang="en-US"/>
           </a:p>
         </p:txBody>
@@ -30953,7 +32016,269 @@
     </p:spTree>
     <p:extLst>
       <p:ext uri="{BB962C8B-B14F-4D97-AF65-F5344CB8AC3E}">
-        <p14:creationId xmlns:p14="http://schemas.microsoft.com/office/powerpoint/2010/main" val="297016650"/>
+        <p14:creationId xmlns:p14="http://schemas.microsoft.com/office/powerpoint/2010/main" val="142533937"/>
+      </p:ext>
+    </p:extLst>
+  </p:cSld>
+  <p:clrMapOvr>
+    <a:masterClrMapping/>
+  </p:clrMapOvr>
+</p:sld>
+</file>
+
+<file path=ppt/slides/slide57.xml><?xml version="1.0" encoding="utf-8"?>
+<p:sld xmlns:a="http://schemas.openxmlformats.org/drawingml/2006/main" xmlns:r="http://schemas.openxmlformats.org/officeDocument/2006/relationships" xmlns:p="http://schemas.openxmlformats.org/presentationml/2006/main">
+  <p:cSld>
+    <p:spTree>
+      <p:nvGrpSpPr>
+        <p:cNvPr id="1" name="">
+          <a:extLst>
+            <a:ext uri="{FF2B5EF4-FFF2-40B4-BE49-F238E27FC236}">
+              <a16:creationId xmlns:a16="http://schemas.microsoft.com/office/drawing/2014/main" id="{578FEFDA-8D32-A23F-DD9D-ED3DD1CBFF98}"/>
+            </a:ext>
+          </a:extLst>
+        </p:cNvPr>
+        <p:cNvGrpSpPr/>
+        <p:nvPr/>
+      </p:nvGrpSpPr>
+      <p:grpSpPr>
+        <a:xfrm>
+          <a:off x="0" y="0"/>
+          <a:ext cx="0" cy="0"/>
+          <a:chOff x="0" y="0"/>
+          <a:chExt cx="0" cy="0"/>
+        </a:xfrm>
+      </p:grpSpPr>
+      <p:pic>
+        <p:nvPicPr>
+          <p:cNvPr id="5" name="Content Placeholder 4">
+            <a:extLst>
+              <a:ext uri="{FF2B5EF4-FFF2-40B4-BE49-F238E27FC236}">
+                <a16:creationId xmlns:a16="http://schemas.microsoft.com/office/drawing/2014/main" id="{2FBF6571-9EFE-82C3-AF01-28D82A591465}"/>
+              </a:ext>
+            </a:extLst>
+          </p:cNvPr>
+          <p:cNvPicPr>
+            <a:picLocks noGrp="1" noChangeAspect="1"/>
+          </p:cNvPicPr>
+          <p:nvPr>
+            <p:ph idx="1"/>
+          </p:nvPr>
+        </p:nvPicPr>
+        <p:blipFill>
+          <a:blip r:embed="rId2">
+            <a:extLst>
+              <a:ext uri="{28A0092B-C50C-407E-A947-70E740481C1C}">
+                <a14:useLocalDpi xmlns:a14="http://schemas.microsoft.com/office/drawing/2010/main" val="0"/>
+              </a:ext>
+            </a:extLst>
+          </a:blip>
+          <a:srcRect/>
+          <a:stretch/>
+        </p:blipFill>
+        <p:spPr>
+          <a:xfrm>
+            <a:off x="1950917" y="566241"/>
+            <a:ext cx="8290166" cy="5725517"/>
+          </a:xfrm>
+        </p:spPr>
+      </p:pic>
+    </p:spTree>
+    <p:extLst>
+      <p:ext uri="{BB962C8B-B14F-4D97-AF65-F5344CB8AC3E}">
+        <p14:creationId xmlns:p14="http://schemas.microsoft.com/office/powerpoint/2010/main" val="2489477932"/>
+      </p:ext>
+    </p:extLst>
+  </p:cSld>
+  <p:clrMapOvr>
+    <a:masterClrMapping/>
+  </p:clrMapOvr>
+</p:sld>
+</file>
+
+<file path=ppt/slides/slide58.xml><?xml version="1.0" encoding="utf-8"?>
+<p:sld xmlns:a="http://schemas.openxmlformats.org/drawingml/2006/main" xmlns:r="http://schemas.openxmlformats.org/officeDocument/2006/relationships" xmlns:p="http://schemas.openxmlformats.org/presentationml/2006/main">
+  <p:cSld>
+    <p:spTree>
+      <p:nvGrpSpPr>
+        <p:cNvPr id="1" name="">
+          <a:extLst>
+            <a:ext uri="{FF2B5EF4-FFF2-40B4-BE49-F238E27FC236}">
+              <a16:creationId xmlns:a16="http://schemas.microsoft.com/office/drawing/2014/main" id="{745A508B-C51E-E0F8-7035-39FF88505E15}"/>
+            </a:ext>
+          </a:extLst>
+        </p:cNvPr>
+        <p:cNvGrpSpPr/>
+        <p:nvPr/>
+      </p:nvGrpSpPr>
+      <p:grpSpPr>
+        <a:xfrm>
+          <a:off x="0" y="0"/>
+          <a:ext cx="0" cy="0"/>
+          <a:chOff x="0" y="0"/>
+          <a:chExt cx="0" cy="0"/>
+        </a:xfrm>
+      </p:grpSpPr>
+      <p:pic>
+        <p:nvPicPr>
+          <p:cNvPr id="5" name="Content Placeholder 4">
+            <a:extLst>
+              <a:ext uri="{FF2B5EF4-FFF2-40B4-BE49-F238E27FC236}">
+                <a16:creationId xmlns:a16="http://schemas.microsoft.com/office/drawing/2014/main" id="{2CE95D3D-2AF7-A03A-57ED-90623A773C61}"/>
+              </a:ext>
+            </a:extLst>
+          </p:cNvPr>
+          <p:cNvPicPr>
+            <a:picLocks noGrp="1" noChangeAspect="1"/>
+          </p:cNvPicPr>
+          <p:nvPr>
+            <p:ph idx="1"/>
+          </p:nvPr>
+        </p:nvPicPr>
+        <p:blipFill>
+          <a:blip r:embed="rId2">
+            <a:extLst>
+              <a:ext uri="{28A0092B-C50C-407E-A947-70E740481C1C}">
+                <a14:useLocalDpi xmlns:a14="http://schemas.microsoft.com/office/drawing/2010/main" val="0"/>
+              </a:ext>
+            </a:extLst>
+          </a:blip>
+          <a:srcRect/>
+          <a:stretch/>
+        </p:blipFill>
+        <p:spPr>
+          <a:xfrm>
+            <a:off x="1950917" y="323126"/>
+            <a:ext cx="8290166" cy="6211748"/>
+          </a:xfrm>
+        </p:spPr>
+      </p:pic>
+    </p:spTree>
+    <p:extLst>
+      <p:ext uri="{BB962C8B-B14F-4D97-AF65-F5344CB8AC3E}">
+        <p14:creationId xmlns:p14="http://schemas.microsoft.com/office/powerpoint/2010/main" val="4014623912"/>
+      </p:ext>
+    </p:extLst>
+  </p:cSld>
+  <p:clrMapOvr>
+    <a:masterClrMapping/>
+  </p:clrMapOvr>
+</p:sld>
+</file>
+
+<file path=ppt/slides/slide59.xml><?xml version="1.0" encoding="utf-8"?>
+<p:sld xmlns:a="http://schemas.openxmlformats.org/drawingml/2006/main" xmlns:r="http://schemas.openxmlformats.org/officeDocument/2006/relationships" xmlns:p="http://schemas.openxmlformats.org/presentationml/2006/main">
+  <p:cSld>
+    <p:spTree>
+      <p:nvGrpSpPr>
+        <p:cNvPr id="1" name="">
+          <a:extLst>
+            <a:ext uri="{FF2B5EF4-FFF2-40B4-BE49-F238E27FC236}">
+              <a16:creationId xmlns:a16="http://schemas.microsoft.com/office/drawing/2014/main" id="{4C32F344-E226-06D2-C318-559F638362D9}"/>
+            </a:ext>
+          </a:extLst>
+        </p:cNvPr>
+        <p:cNvGrpSpPr/>
+        <p:nvPr/>
+      </p:nvGrpSpPr>
+      <p:grpSpPr>
+        <a:xfrm>
+          <a:off x="0" y="0"/>
+          <a:ext cx="0" cy="0"/>
+          <a:chOff x="0" y="0"/>
+          <a:chExt cx="0" cy="0"/>
+        </a:xfrm>
+      </p:grpSpPr>
+      <p:pic>
+        <p:nvPicPr>
+          <p:cNvPr id="5" name="Content Placeholder 4">
+            <a:extLst>
+              <a:ext uri="{FF2B5EF4-FFF2-40B4-BE49-F238E27FC236}">
+                <a16:creationId xmlns:a16="http://schemas.microsoft.com/office/drawing/2014/main" id="{00D7AB72-3A0B-DF93-E72C-4D4340D9A01B}"/>
+              </a:ext>
+            </a:extLst>
+          </p:cNvPr>
+          <p:cNvPicPr>
+            <a:picLocks noGrp="1" noChangeAspect="1"/>
+          </p:cNvPicPr>
+          <p:nvPr>
+            <p:ph idx="1"/>
+          </p:nvPr>
+        </p:nvPicPr>
+        <p:blipFill>
+          <a:blip r:embed="rId2">
+            <a:extLst>
+              <a:ext uri="{28A0092B-C50C-407E-A947-70E740481C1C}">
+                <a14:useLocalDpi xmlns:a14="http://schemas.microsoft.com/office/drawing/2010/main" val="0"/>
+              </a:ext>
+            </a:extLst>
+          </a:blip>
+          <a:srcRect/>
+          <a:stretch/>
+        </p:blipFill>
+        <p:spPr>
+          <a:xfrm>
+            <a:off x="1950917" y="323126"/>
+            <a:ext cx="8290166" cy="6211748"/>
+          </a:xfrm>
+        </p:spPr>
+      </p:pic>
+      <p:sp>
+        <p:nvSpPr>
+          <p:cNvPr id="2" name="Rectangle 1">
+            <a:extLst>
+              <a:ext uri="{FF2B5EF4-FFF2-40B4-BE49-F238E27FC236}">
+                <a16:creationId xmlns:a16="http://schemas.microsoft.com/office/drawing/2014/main" id="{3225720B-8631-9B74-19C1-8BA8CA6FFDF4}"/>
+              </a:ext>
+            </a:extLst>
+          </p:cNvPr>
+          <p:cNvSpPr/>
+          <p:nvPr/>
+        </p:nvSpPr>
+        <p:spPr>
+          <a:xfrm>
+            <a:off x="8538210" y="5140414"/>
+            <a:ext cx="1074420" cy="1394460"/>
+          </a:xfrm>
+          <a:prstGeom prst="rect">
+            <a:avLst/>
+          </a:prstGeom>
+          <a:solidFill>
+            <a:schemeClr val="bg1"/>
+          </a:solidFill>
+          <a:ln>
+            <a:noFill/>
+          </a:ln>
+        </p:spPr>
+        <p:style>
+          <a:lnRef idx="2">
+            <a:schemeClr val="accent1">
+              <a:shade val="15000"/>
+            </a:schemeClr>
+          </a:lnRef>
+          <a:fillRef idx="1">
+            <a:schemeClr val="accent1"/>
+          </a:fillRef>
+          <a:effectRef idx="0">
+            <a:schemeClr val="accent1"/>
+          </a:effectRef>
+          <a:fontRef idx="minor">
+            <a:schemeClr val="lt1"/>
+          </a:fontRef>
+        </p:style>
+        <p:txBody>
+          <a:bodyPr rtlCol="0" anchor="ctr"/>
+          <a:lstStyle/>
+          <a:p>
+            <a:pPr algn="ctr"/>
+            <a:endParaRPr lang="en-US"/>
+          </a:p>
+        </p:txBody>
+      </p:sp>
+    </p:spTree>
+    <p:extLst>
+      <p:ext uri="{BB962C8B-B14F-4D97-AF65-F5344CB8AC3E}">
+        <p14:creationId xmlns:p14="http://schemas.microsoft.com/office/powerpoint/2010/main" val="477118837"/>
       </p:ext>
     </p:extLst>
   </p:cSld>
@@ -31233,7 +32558,495 @@
 </p:sld>
 </file>
 
-<file path=ppt/slides/slide7.xml><?xml version="1.0" encoding="utf-8"?>
+<file path=ppt/slides/slide60.xml><?xml version="1.0" encoding="utf-8"?>
+<p:sld xmlns:a="http://schemas.openxmlformats.org/drawingml/2006/main" xmlns:r="http://schemas.openxmlformats.org/officeDocument/2006/relationships" xmlns:p="http://schemas.openxmlformats.org/presentationml/2006/main">
+  <p:cSld>
+    <p:spTree>
+      <p:nvGrpSpPr>
+        <p:cNvPr id="1" name="">
+          <a:extLst>
+            <a:ext uri="{FF2B5EF4-FFF2-40B4-BE49-F238E27FC236}">
+              <a16:creationId xmlns:a16="http://schemas.microsoft.com/office/drawing/2014/main" id="{4CB8A116-DD44-4763-EB5C-B89C4932A112}"/>
+            </a:ext>
+          </a:extLst>
+        </p:cNvPr>
+        <p:cNvGrpSpPr/>
+        <p:nvPr/>
+      </p:nvGrpSpPr>
+      <p:grpSpPr>
+        <a:xfrm>
+          <a:off x="0" y="0"/>
+          <a:ext cx="0" cy="0"/>
+          <a:chOff x="0" y="0"/>
+          <a:chExt cx="0" cy="0"/>
+        </a:xfrm>
+      </p:grpSpPr>
+      <p:pic>
+        <p:nvPicPr>
+          <p:cNvPr id="5" name="Content Placeholder 4">
+            <a:extLst>
+              <a:ext uri="{FF2B5EF4-FFF2-40B4-BE49-F238E27FC236}">
+                <a16:creationId xmlns:a16="http://schemas.microsoft.com/office/drawing/2014/main" id="{51D71EDE-56ED-793D-B52A-78F9C656F258}"/>
+              </a:ext>
+            </a:extLst>
+          </p:cNvPr>
+          <p:cNvPicPr>
+            <a:picLocks noGrp="1" noChangeAspect="1"/>
+          </p:cNvPicPr>
+          <p:nvPr>
+            <p:ph idx="1"/>
+          </p:nvPr>
+        </p:nvPicPr>
+        <p:blipFill>
+          <a:blip r:embed="rId2">
+            <a:extLst>
+              <a:ext uri="{28A0092B-C50C-407E-A947-70E740481C1C}">
+                <a14:useLocalDpi xmlns:a14="http://schemas.microsoft.com/office/drawing/2010/main" val="0"/>
+              </a:ext>
+            </a:extLst>
+          </a:blip>
+          <a:srcRect/>
+          <a:stretch/>
+        </p:blipFill>
+        <p:spPr>
+          <a:xfrm>
+            <a:off x="1950917" y="161563"/>
+            <a:ext cx="8290166" cy="6534874"/>
+          </a:xfrm>
+        </p:spPr>
+      </p:pic>
+      <p:sp>
+        <p:nvSpPr>
+          <p:cNvPr id="2" name="Rectangle 1">
+            <a:extLst>
+              <a:ext uri="{FF2B5EF4-FFF2-40B4-BE49-F238E27FC236}">
+                <a16:creationId xmlns:a16="http://schemas.microsoft.com/office/drawing/2014/main" id="{D5712EFC-E1BE-6E27-D5C6-1F101FE53ECB}"/>
+              </a:ext>
+            </a:extLst>
+          </p:cNvPr>
+          <p:cNvSpPr/>
+          <p:nvPr/>
+        </p:nvSpPr>
+        <p:spPr>
+          <a:xfrm>
+            <a:off x="8652510" y="5246370"/>
+            <a:ext cx="1074420" cy="1143000"/>
+          </a:xfrm>
+          <a:prstGeom prst="rect">
+            <a:avLst/>
+          </a:prstGeom>
+          <a:solidFill>
+            <a:schemeClr val="bg1"/>
+          </a:solidFill>
+          <a:ln>
+            <a:noFill/>
+          </a:ln>
+        </p:spPr>
+        <p:style>
+          <a:lnRef idx="2">
+            <a:schemeClr val="accent1">
+              <a:shade val="15000"/>
+            </a:schemeClr>
+          </a:lnRef>
+          <a:fillRef idx="1">
+            <a:schemeClr val="accent1"/>
+          </a:fillRef>
+          <a:effectRef idx="0">
+            <a:schemeClr val="accent1"/>
+          </a:effectRef>
+          <a:fontRef idx="minor">
+            <a:schemeClr val="lt1"/>
+          </a:fontRef>
+        </p:style>
+        <p:txBody>
+          <a:bodyPr rtlCol="0" anchor="ctr"/>
+          <a:lstStyle/>
+          <a:p>
+            <a:pPr algn="ctr"/>
+            <a:endParaRPr lang="en-US"/>
+          </a:p>
+        </p:txBody>
+      </p:sp>
+    </p:spTree>
+    <p:extLst>
+      <p:ext uri="{BB962C8B-B14F-4D97-AF65-F5344CB8AC3E}">
+        <p14:creationId xmlns:p14="http://schemas.microsoft.com/office/powerpoint/2010/main" val="1081312711"/>
+      </p:ext>
+    </p:extLst>
+  </p:cSld>
+  <p:clrMapOvr>
+    <a:masterClrMapping/>
+  </p:clrMapOvr>
+</p:sld>
+</file>
+
+<file path=ppt/slides/slide61.xml><?xml version="1.0" encoding="utf-8"?>
+<p:sld xmlns:a="http://schemas.openxmlformats.org/drawingml/2006/main" xmlns:r="http://schemas.openxmlformats.org/officeDocument/2006/relationships" xmlns:p="http://schemas.openxmlformats.org/presentationml/2006/main">
+  <p:cSld>
+    <p:spTree>
+      <p:nvGrpSpPr>
+        <p:cNvPr id="1" name="">
+          <a:extLst>
+            <a:ext uri="{FF2B5EF4-FFF2-40B4-BE49-F238E27FC236}">
+              <a16:creationId xmlns:a16="http://schemas.microsoft.com/office/drawing/2014/main" id="{BC2B5733-7457-8E0E-A3C6-A4C312B51C47}"/>
+            </a:ext>
+          </a:extLst>
+        </p:cNvPr>
+        <p:cNvGrpSpPr/>
+        <p:nvPr/>
+      </p:nvGrpSpPr>
+      <p:grpSpPr>
+        <a:xfrm>
+          <a:off x="0" y="0"/>
+          <a:ext cx="0" cy="0"/>
+          <a:chOff x="0" y="0"/>
+          <a:chExt cx="0" cy="0"/>
+        </a:xfrm>
+      </p:grpSpPr>
+      <p:pic>
+        <p:nvPicPr>
+          <p:cNvPr id="5" name="Content Placeholder 4">
+            <a:extLst>
+              <a:ext uri="{FF2B5EF4-FFF2-40B4-BE49-F238E27FC236}">
+                <a16:creationId xmlns:a16="http://schemas.microsoft.com/office/drawing/2014/main" id="{89218D72-699D-208D-728E-83DE1AFB84D4}"/>
+              </a:ext>
+            </a:extLst>
+          </p:cNvPr>
+          <p:cNvPicPr>
+            <a:picLocks noGrp="1" noChangeAspect="1"/>
+          </p:cNvPicPr>
+          <p:nvPr>
+            <p:ph idx="1"/>
+          </p:nvPr>
+        </p:nvPicPr>
+        <p:blipFill>
+          <a:blip r:embed="rId2">
+            <a:extLst>
+              <a:ext uri="{28A0092B-C50C-407E-A947-70E740481C1C}">
+                <a14:useLocalDpi xmlns:a14="http://schemas.microsoft.com/office/drawing/2010/main" val="0"/>
+              </a:ext>
+            </a:extLst>
+          </a:blip>
+          <a:srcRect/>
+          <a:stretch/>
+        </p:blipFill>
+        <p:spPr>
+          <a:xfrm>
+            <a:off x="1950917" y="194310"/>
+            <a:ext cx="8290166" cy="6340564"/>
+          </a:xfrm>
+        </p:spPr>
+      </p:pic>
+      <p:sp>
+        <p:nvSpPr>
+          <p:cNvPr id="2" name="Rectangle 1">
+            <a:extLst>
+              <a:ext uri="{FF2B5EF4-FFF2-40B4-BE49-F238E27FC236}">
+                <a16:creationId xmlns:a16="http://schemas.microsoft.com/office/drawing/2014/main" id="{0BD0A1C1-C85D-424D-020A-894D5E8C8B5C}"/>
+              </a:ext>
+            </a:extLst>
+          </p:cNvPr>
+          <p:cNvSpPr/>
+          <p:nvPr/>
+        </p:nvSpPr>
+        <p:spPr>
+          <a:xfrm>
+            <a:off x="8503920" y="4652010"/>
+            <a:ext cx="1074420" cy="1885950"/>
+          </a:xfrm>
+          <a:prstGeom prst="rect">
+            <a:avLst/>
+          </a:prstGeom>
+          <a:solidFill>
+            <a:schemeClr val="bg1"/>
+          </a:solidFill>
+          <a:ln>
+            <a:noFill/>
+          </a:ln>
+        </p:spPr>
+        <p:style>
+          <a:lnRef idx="2">
+            <a:schemeClr val="accent1">
+              <a:shade val="15000"/>
+            </a:schemeClr>
+          </a:lnRef>
+          <a:fillRef idx="1">
+            <a:schemeClr val="accent1"/>
+          </a:fillRef>
+          <a:effectRef idx="0">
+            <a:schemeClr val="accent1"/>
+          </a:effectRef>
+          <a:fontRef idx="minor">
+            <a:schemeClr val="lt1"/>
+          </a:fontRef>
+        </p:style>
+        <p:txBody>
+          <a:bodyPr rtlCol="0" anchor="ctr"/>
+          <a:lstStyle/>
+          <a:p>
+            <a:pPr algn="ctr"/>
+            <a:endParaRPr lang="en-US"/>
+          </a:p>
+        </p:txBody>
+      </p:sp>
+    </p:spTree>
+    <p:extLst>
+      <p:ext uri="{BB962C8B-B14F-4D97-AF65-F5344CB8AC3E}">
+        <p14:creationId xmlns:p14="http://schemas.microsoft.com/office/powerpoint/2010/main" val="2201613293"/>
+      </p:ext>
+    </p:extLst>
+  </p:cSld>
+  <p:clrMapOvr>
+    <a:masterClrMapping/>
+  </p:clrMapOvr>
+</p:sld>
+</file>
+
+<file path=ppt/slides/slide62.xml><?xml version="1.0" encoding="utf-8"?>
+<p:sld xmlns:a="http://schemas.openxmlformats.org/drawingml/2006/main" xmlns:r="http://schemas.openxmlformats.org/officeDocument/2006/relationships" xmlns:p="http://schemas.openxmlformats.org/presentationml/2006/main">
+  <p:cSld>
+    <p:spTree>
+      <p:nvGrpSpPr>
+        <p:cNvPr id="1" name="">
+          <a:extLst>
+            <a:ext uri="{FF2B5EF4-FFF2-40B4-BE49-F238E27FC236}">
+              <a16:creationId xmlns:a16="http://schemas.microsoft.com/office/drawing/2014/main" id="{0F29304D-D1D2-0FCC-53DE-54D97CB29069}"/>
+            </a:ext>
+          </a:extLst>
+        </p:cNvPr>
+        <p:cNvGrpSpPr/>
+        <p:nvPr/>
+      </p:nvGrpSpPr>
+      <p:grpSpPr>
+        <a:xfrm>
+          <a:off x="0" y="0"/>
+          <a:ext cx="0" cy="0"/>
+          <a:chOff x="0" y="0"/>
+          <a:chExt cx="0" cy="0"/>
+        </a:xfrm>
+      </p:grpSpPr>
+      <p:pic>
+        <p:nvPicPr>
+          <p:cNvPr id="5" name="Content Placeholder 4">
+            <a:extLst>
+              <a:ext uri="{FF2B5EF4-FFF2-40B4-BE49-F238E27FC236}">
+                <a16:creationId xmlns:a16="http://schemas.microsoft.com/office/drawing/2014/main" id="{0A4A2703-83D7-3250-E821-C9C5E29027D1}"/>
+              </a:ext>
+            </a:extLst>
+          </p:cNvPr>
+          <p:cNvPicPr>
+            <a:picLocks noGrp="1" noChangeAspect="1"/>
+          </p:cNvPicPr>
+          <p:nvPr>
+            <p:ph idx="1"/>
+          </p:nvPr>
+        </p:nvPicPr>
+        <p:blipFill>
+          <a:blip r:embed="rId2">
+            <a:extLst>
+              <a:ext uri="{28A0092B-C50C-407E-A947-70E740481C1C}">
+                <a14:useLocalDpi xmlns:a14="http://schemas.microsoft.com/office/drawing/2010/main" val="0"/>
+              </a:ext>
+            </a:extLst>
+          </a:blip>
+          <a:srcRect/>
+          <a:stretch/>
+        </p:blipFill>
+        <p:spPr>
+          <a:xfrm>
+            <a:off x="2173703" y="164128"/>
+            <a:ext cx="7844593" cy="6529744"/>
+          </a:xfrm>
+        </p:spPr>
+      </p:pic>
+      <p:sp>
+        <p:nvSpPr>
+          <p:cNvPr id="2" name="Rectangle 1">
+            <a:extLst>
+              <a:ext uri="{FF2B5EF4-FFF2-40B4-BE49-F238E27FC236}">
+                <a16:creationId xmlns:a16="http://schemas.microsoft.com/office/drawing/2014/main" id="{7A2AFD58-E642-EF93-FDDF-771063E2D875}"/>
+              </a:ext>
+            </a:extLst>
+          </p:cNvPr>
+          <p:cNvSpPr/>
+          <p:nvPr/>
+        </p:nvSpPr>
+        <p:spPr>
+          <a:xfrm>
+            <a:off x="8549640" y="5029200"/>
+            <a:ext cx="1074420" cy="1497330"/>
+          </a:xfrm>
+          <a:prstGeom prst="rect">
+            <a:avLst/>
+          </a:prstGeom>
+          <a:solidFill>
+            <a:schemeClr val="bg1"/>
+          </a:solidFill>
+          <a:ln>
+            <a:noFill/>
+          </a:ln>
+        </p:spPr>
+        <p:style>
+          <a:lnRef idx="2">
+            <a:schemeClr val="accent1">
+              <a:shade val="15000"/>
+            </a:schemeClr>
+          </a:lnRef>
+          <a:fillRef idx="1">
+            <a:schemeClr val="accent1"/>
+          </a:fillRef>
+          <a:effectRef idx="0">
+            <a:schemeClr val="accent1"/>
+          </a:effectRef>
+          <a:fontRef idx="minor">
+            <a:schemeClr val="lt1"/>
+          </a:fontRef>
+        </p:style>
+        <p:txBody>
+          <a:bodyPr rtlCol="0" anchor="ctr"/>
+          <a:lstStyle/>
+          <a:p>
+            <a:pPr algn="ctr"/>
+            <a:endParaRPr lang="en-US"/>
+          </a:p>
+        </p:txBody>
+      </p:sp>
+    </p:spTree>
+    <p:extLst>
+      <p:ext uri="{BB962C8B-B14F-4D97-AF65-F5344CB8AC3E}">
+        <p14:creationId xmlns:p14="http://schemas.microsoft.com/office/powerpoint/2010/main" val="2688949156"/>
+      </p:ext>
+    </p:extLst>
+  </p:cSld>
+  <p:clrMapOvr>
+    <a:masterClrMapping/>
+  </p:clrMapOvr>
+</p:sld>
+</file>
+
+<file path=ppt/slides/slide63.xml><?xml version="1.0" encoding="utf-8"?>
+<p:sld xmlns:a="http://schemas.openxmlformats.org/drawingml/2006/main" xmlns:r="http://schemas.openxmlformats.org/officeDocument/2006/relationships" xmlns:p="http://schemas.openxmlformats.org/presentationml/2006/main">
+  <p:cSld>
+    <p:spTree>
+      <p:nvGrpSpPr>
+        <p:cNvPr id="1" name="">
+          <a:extLst>
+            <a:ext uri="{FF2B5EF4-FFF2-40B4-BE49-F238E27FC236}">
+              <a16:creationId xmlns:a16="http://schemas.microsoft.com/office/drawing/2014/main" id="{D7556B53-6D05-5BA8-DA7D-019D535FDD8D}"/>
+            </a:ext>
+          </a:extLst>
+        </p:cNvPr>
+        <p:cNvGrpSpPr/>
+        <p:nvPr/>
+      </p:nvGrpSpPr>
+      <p:grpSpPr>
+        <a:xfrm>
+          <a:off x="0" y="0"/>
+          <a:ext cx="0" cy="0"/>
+          <a:chOff x="0" y="0"/>
+          <a:chExt cx="0" cy="0"/>
+        </a:xfrm>
+      </p:grpSpPr>
+      <p:pic>
+        <p:nvPicPr>
+          <p:cNvPr id="5" name="Content Placeholder 4">
+            <a:extLst>
+              <a:ext uri="{FF2B5EF4-FFF2-40B4-BE49-F238E27FC236}">
+                <a16:creationId xmlns:a16="http://schemas.microsoft.com/office/drawing/2014/main" id="{354AD74F-082A-C3A5-D068-421EE199B4E3}"/>
+              </a:ext>
+            </a:extLst>
+          </p:cNvPr>
+          <p:cNvPicPr>
+            <a:picLocks noGrp="1" noChangeAspect="1"/>
+          </p:cNvPicPr>
+          <p:nvPr>
+            <p:ph idx="1"/>
+          </p:nvPr>
+        </p:nvPicPr>
+        <p:blipFill>
+          <a:blip r:embed="rId2">
+            <a:extLst>
+              <a:ext uri="{28A0092B-C50C-407E-A947-70E740481C1C}">
+                <a14:useLocalDpi xmlns:a14="http://schemas.microsoft.com/office/drawing/2010/main" val="0"/>
+              </a:ext>
+            </a:extLst>
+          </a:blip>
+          <a:srcRect/>
+          <a:stretch/>
+        </p:blipFill>
+        <p:spPr>
+          <a:xfrm>
+            <a:off x="2173703" y="164128"/>
+            <a:ext cx="7844593" cy="6529744"/>
+          </a:xfrm>
+        </p:spPr>
+      </p:pic>
+      <p:sp>
+        <p:nvSpPr>
+          <p:cNvPr id="2" name="Rectangle 1">
+            <a:extLst>
+              <a:ext uri="{FF2B5EF4-FFF2-40B4-BE49-F238E27FC236}">
+                <a16:creationId xmlns:a16="http://schemas.microsoft.com/office/drawing/2014/main" id="{93F12648-374A-79DC-B482-86C23C9193BC}"/>
+              </a:ext>
+            </a:extLst>
+          </p:cNvPr>
+          <p:cNvSpPr/>
+          <p:nvPr/>
+        </p:nvSpPr>
+        <p:spPr>
+          <a:xfrm>
+            <a:off x="8503920" y="5394960"/>
+            <a:ext cx="1074420" cy="1143000"/>
+          </a:xfrm>
+          <a:prstGeom prst="rect">
+            <a:avLst/>
+          </a:prstGeom>
+          <a:solidFill>
+            <a:schemeClr val="bg1"/>
+          </a:solidFill>
+          <a:ln>
+            <a:noFill/>
+          </a:ln>
+        </p:spPr>
+        <p:style>
+          <a:lnRef idx="2">
+            <a:schemeClr val="accent1">
+              <a:shade val="15000"/>
+            </a:schemeClr>
+          </a:lnRef>
+          <a:fillRef idx="1">
+            <a:schemeClr val="accent1"/>
+          </a:fillRef>
+          <a:effectRef idx="0">
+            <a:schemeClr val="accent1"/>
+          </a:effectRef>
+          <a:fontRef idx="minor">
+            <a:schemeClr val="lt1"/>
+          </a:fontRef>
+        </p:style>
+        <p:txBody>
+          <a:bodyPr rtlCol="0" anchor="ctr"/>
+          <a:lstStyle/>
+          <a:p>
+            <a:pPr algn="ctr"/>
+            <a:endParaRPr lang="en-US"/>
+          </a:p>
+        </p:txBody>
+      </p:sp>
+    </p:spTree>
+    <p:extLst>
+      <p:ext uri="{BB962C8B-B14F-4D97-AF65-F5344CB8AC3E}">
+        <p14:creationId xmlns:p14="http://schemas.microsoft.com/office/powerpoint/2010/main" val="493499187"/>
+      </p:ext>
+    </p:extLst>
+  </p:cSld>
+  <p:clrMapOvr>
+    <a:masterClrMapping/>
+  </p:clrMapOvr>
+</p:sld>
+</file>
+
+<file path=ppt/slides/slide64.xml><?xml version="1.0" encoding="utf-8"?>
 <p:sld xmlns:a="http://schemas.openxmlformats.org/drawingml/2006/main" xmlns:r="http://schemas.openxmlformats.org/officeDocument/2006/relationships" xmlns:p="http://schemas.openxmlformats.org/presentationml/2006/main">
   <p:cSld>
     <p:spTree>
@@ -31255,7 +33068,7 @@
           <p:cNvPr id="2" name="Title 1">
             <a:extLst>
               <a:ext uri="{FF2B5EF4-FFF2-40B4-BE49-F238E27FC236}">
-                <a16:creationId xmlns:a16="http://schemas.microsoft.com/office/drawing/2014/main" id="{5BDC692E-2B09-E63D-90C2-78DF7DE65F46}"/>
+                <a16:creationId xmlns:a16="http://schemas.microsoft.com/office/drawing/2014/main" id="{D08A625E-726F-D832-DF38-55A24DBF7486}"/>
               </a:ext>
             </a:extLst>
           </p:cNvPr>
@@ -31273,11 +33086,191 @@
           <a:p>
             <a:r>
               <a:rPr lang="en-US" dirty="0"/>
-              <a:t>Building metaphor</a:t>
+              <a:t>Time complexity of heap operations</a:t>
             </a:r>
           </a:p>
         </p:txBody>
       </p:sp>
+      <p:sp>
+        <p:nvSpPr>
+          <p:cNvPr id="3" name="Content Placeholder 2">
+            <a:extLst>
+              <a:ext uri="{FF2B5EF4-FFF2-40B4-BE49-F238E27FC236}">
+                <a16:creationId xmlns:a16="http://schemas.microsoft.com/office/drawing/2014/main" id="{045669BD-8623-05EA-51BB-2EB67EBCB360}"/>
+              </a:ext>
+            </a:extLst>
+          </p:cNvPr>
+          <p:cNvSpPr>
+            <a:spLocks noGrp="1"/>
+          </p:cNvSpPr>
+          <p:nvPr>
+            <p:ph idx="1"/>
+          </p:nvPr>
+        </p:nvSpPr>
+        <p:spPr/>
+        <p:txBody>
+          <a:bodyPr/>
+          <a:lstStyle/>
+          <a:p>
+            <a:r>
+              <a:rPr lang="en-US" dirty="0"/>
+              <a:t>Inserting an element – </a:t>
+            </a:r>
+            <a:r>
+              <a:rPr lang="en-US" i="1" dirty="0"/>
+              <a:t>O(lg(n))</a:t>
+            </a:r>
+          </a:p>
+          <a:p>
+            <a:r>
+              <a:rPr lang="en-US" dirty="0"/>
+              <a:t>Removing an element – </a:t>
+            </a:r>
+            <a:r>
+              <a:rPr lang="en-US" i="1" dirty="0"/>
+              <a:t>O(lg(n))</a:t>
+            </a:r>
+            <a:endParaRPr lang="en-US" dirty="0"/>
+          </a:p>
+        </p:txBody>
+      </p:sp>
+    </p:spTree>
+    <p:extLst>
+      <p:ext uri="{BB962C8B-B14F-4D97-AF65-F5344CB8AC3E}">
+        <p14:creationId xmlns:p14="http://schemas.microsoft.com/office/powerpoint/2010/main" val="973608631"/>
+      </p:ext>
+    </p:extLst>
+  </p:cSld>
+  <p:clrMapOvr>
+    <a:masterClrMapping/>
+  </p:clrMapOvr>
+</p:sld>
+</file>
+
+<file path=ppt/slides/slide65.xml><?xml version="1.0" encoding="utf-8"?>
+<p:sld xmlns:a="http://schemas.openxmlformats.org/drawingml/2006/main" xmlns:r="http://schemas.openxmlformats.org/officeDocument/2006/relationships" xmlns:p="http://schemas.openxmlformats.org/presentationml/2006/main">
+  <p:cSld>
+    <p:spTree>
+      <p:nvGrpSpPr>
+        <p:cNvPr id="1" name="">
+          <a:extLst>
+            <a:ext uri="{FF2B5EF4-FFF2-40B4-BE49-F238E27FC236}">
+              <a16:creationId xmlns:a16="http://schemas.microsoft.com/office/drawing/2014/main" id="{868059CB-17B8-1685-B811-7A7F1BC007C4}"/>
+            </a:ext>
+          </a:extLst>
+        </p:cNvPr>
+        <p:cNvGrpSpPr/>
+        <p:nvPr/>
+      </p:nvGrpSpPr>
+      <p:grpSpPr>
+        <a:xfrm>
+          <a:off x="0" y="0"/>
+          <a:ext cx="0" cy="0"/>
+          <a:chOff x="0" y="0"/>
+          <a:chExt cx="0" cy="0"/>
+        </a:xfrm>
+      </p:grpSpPr>
+      <p:sp>
+        <p:nvSpPr>
+          <p:cNvPr id="2" name="Title 1">
+            <a:extLst>
+              <a:ext uri="{FF2B5EF4-FFF2-40B4-BE49-F238E27FC236}">
+                <a16:creationId xmlns:a16="http://schemas.microsoft.com/office/drawing/2014/main" id="{58233560-B114-FE6F-568A-4D9763C07085}"/>
+              </a:ext>
+            </a:extLst>
+          </p:cNvPr>
+          <p:cNvSpPr>
+            <a:spLocks noGrp="1"/>
+          </p:cNvSpPr>
+          <p:nvPr>
+            <p:ph type="title"/>
+          </p:nvPr>
+        </p:nvSpPr>
+        <p:spPr/>
+        <p:txBody>
+          <a:bodyPr/>
+          <a:lstStyle/>
+          <a:p>
+            <a:r>
+              <a:rPr lang="en-US" dirty="0"/>
+              <a:t>What about building the Initial heap?</a:t>
+            </a:r>
+          </a:p>
+        </p:txBody>
+      </p:sp>
+      <p:sp>
+        <p:nvSpPr>
+          <p:cNvPr id="3" name="Content Placeholder 2">
+            <a:extLst>
+              <a:ext uri="{FF2B5EF4-FFF2-40B4-BE49-F238E27FC236}">
+                <a16:creationId xmlns:a16="http://schemas.microsoft.com/office/drawing/2014/main" id="{77AFF32B-9B83-5BEB-3007-30FE7AF1B180}"/>
+              </a:ext>
+            </a:extLst>
+          </p:cNvPr>
+          <p:cNvSpPr>
+            <a:spLocks noGrp="1"/>
+          </p:cNvSpPr>
+          <p:nvPr>
+            <p:ph idx="1"/>
+          </p:nvPr>
+        </p:nvSpPr>
+        <p:spPr/>
+        <p:txBody>
+          <a:bodyPr/>
+          <a:lstStyle/>
+          <a:p>
+            <a:r>
+              <a:rPr lang="en-US" dirty="0"/>
+              <a:t>With the right implementation – </a:t>
+            </a:r>
+            <a:r>
+              <a:rPr lang="en-US" i="1" dirty="0"/>
+              <a:t>O(n)</a:t>
+            </a:r>
+          </a:p>
+          <a:p>
+            <a:pPr lvl="1"/>
+            <a:r>
+              <a:rPr lang="en-US" i="1" dirty="0"/>
+              <a:t>Homework for extra points: find the proof!</a:t>
+            </a:r>
+            <a:endParaRPr lang="en-US" dirty="0"/>
+          </a:p>
+          <a:p>
+            <a:endParaRPr lang="en-US" dirty="0"/>
+          </a:p>
+        </p:txBody>
+      </p:sp>
+    </p:spTree>
+    <p:extLst>
+      <p:ext uri="{BB962C8B-B14F-4D97-AF65-F5344CB8AC3E}">
+        <p14:creationId xmlns:p14="http://schemas.microsoft.com/office/powerpoint/2010/main" val="420635686"/>
+      </p:ext>
+    </p:extLst>
+  </p:cSld>
+  <p:clrMapOvr>
+    <a:masterClrMapping/>
+  </p:clrMapOvr>
+</p:sld>
+</file>
+
+<file path=ppt/slides/slide7.xml><?xml version="1.0" encoding="utf-8"?>
+<p:sld xmlns:a="http://schemas.openxmlformats.org/drawingml/2006/main" xmlns:r="http://schemas.openxmlformats.org/officeDocument/2006/relationships" xmlns:p="http://schemas.openxmlformats.org/presentationml/2006/main">
+  <p:cSld>
+    <p:spTree>
+      <p:nvGrpSpPr>
+        <p:cNvPr id="1" name=""/>
+        <p:cNvGrpSpPr/>
+        <p:nvPr/>
+      </p:nvGrpSpPr>
+      <p:grpSpPr>
+        <a:xfrm>
+          <a:off x="0" y="0"/>
+          <a:ext cx="0" cy="0"/>
+          <a:chOff x="0" y="0"/>
+          <a:chExt cx="0" cy="0"/>
+        </a:xfrm>
+      </p:grpSpPr>
       <p:graphicFrame>
         <p:nvGraphicFramePr>
           <p:cNvPr id="5" name="Content Placeholder 2">
@@ -31294,14 +33287,14 @@
             <p:ph idx="1"/>
             <p:extLst>
               <p:ext uri="{D42A27DB-BD31-4B8C-83A1-F6EECF244321}">
-                <p14:modId xmlns:p14="http://schemas.microsoft.com/office/powerpoint/2010/main" val="3240205918"/>
+                <p14:modId xmlns:p14="http://schemas.microsoft.com/office/powerpoint/2010/main" val="3815092329"/>
               </p:ext>
             </p:extLst>
           </p:nvPr>
         </p:nvGraphicFramePr>
         <p:xfrm>
-          <a:off x="838200" y="1825625"/>
-          <a:ext cx="10515600" cy="4351338"/>
+          <a:off x="367665" y="854868"/>
+          <a:ext cx="11456670" cy="5148263"/>
         </p:xfrm>
         <a:graphic>
           <a:graphicData uri="http://schemas.openxmlformats.org/drawingml/2006/diagram">
@@ -31522,7 +33515,7 @@
           <a:p>
             <a:r>
               <a:rPr lang="en-US" dirty="0"/>
-              <a:t>Compound data types – fixed size in memory</a:t>
+              <a:t>Composite data types – fixed size in memory</a:t>
             </a:r>
           </a:p>
         </p:txBody>

</xml_diff>

<commit_message>
Finish abstract data types by adding prio Q and complete sixth lecture about binary trees, sets and maps - ordered versions only. TODO Hash tables, unordered map, set
</commit_message>
<xml_diff>
--- a/MyOwnPresentations/Abstract_Datatypes_V.pptx
+++ b/MyOwnPresentations/Abstract_Datatypes_V.pptx
@@ -12278,7 +12278,7 @@
           <a:p>
             <a:fld id="{16652C1E-0A75-4E3C-905C-182B2377573E}" type="datetimeFigureOut">
               <a:rPr lang="en-US" smtClean="0"/>
-              <a:t>9/4/2025</a:t>
+              <a:t>9/5/2025</a:t>
             </a:fld>
             <a:endParaRPr lang="en-US"/>
           </a:p>
@@ -12476,7 +12476,7 @@
           <a:p>
             <a:fld id="{16652C1E-0A75-4E3C-905C-182B2377573E}" type="datetimeFigureOut">
               <a:rPr lang="en-US" smtClean="0"/>
-              <a:t>9/4/2025</a:t>
+              <a:t>9/5/2025</a:t>
             </a:fld>
             <a:endParaRPr lang="en-US"/>
           </a:p>
@@ -12684,7 +12684,7 @@
           <a:p>
             <a:fld id="{16652C1E-0A75-4E3C-905C-182B2377573E}" type="datetimeFigureOut">
               <a:rPr lang="en-US" smtClean="0"/>
-              <a:t>9/4/2025</a:t>
+              <a:t>9/5/2025</a:t>
             </a:fld>
             <a:endParaRPr lang="en-US"/>
           </a:p>
@@ -12904,7 +12904,7 @@
           <a:p>
             <a:fld id="{5C041930-F8FC-4542-827E-E504F4750562}" type="datetimeFigureOut">
               <a:rPr lang="en-US" smtClean="0"/>
-              <a:t>9/4/2025</a:t>
+              <a:t>9/5/2025</a:t>
             </a:fld>
             <a:endParaRPr lang="en-US"/>
           </a:p>
@@ -13102,7 +13102,7 @@
           <a:p>
             <a:fld id="{5C041930-F8FC-4542-827E-E504F4750562}" type="datetimeFigureOut">
               <a:rPr lang="en-US" smtClean="0"/>
-              <a:t>9/4/2025</a:t>
+              <a:t>9/5/2025</a:t>
             </a:fld>
             <a:endParaRPr lang="en-US"/>
           </a:p>
@@ -13377,7 +13377,7 @@
           <a:p>
             <a:fld id="{5C041930-F8FC-4542-827E-E504F4750562}" type="datetimeFigureOut">
               <a:rPr lang="en-US" smtClean="0"/>
-              <a:t>9/4/2025</a:t>
+              <a:t>9/5/2025</a:t>
             </a:fld>
             <a:endParaRPr lang="en-US"/>
           </a:p>
@@ -13642,7 +13642,7 @@
           <a:p>
             <a:fld id="{5C041930-F8FC-4542-827E-E504F4750562}" type="datetimeFigureOut">
               <a:rPr lang="en-US" smtClean="0"/>
-              <a:t>9/4/2025</a:t>
+              <a:t>9/5/2025</a:t>
             </a:fld>
             <a:endParaRPr lang="en-US"/>
           </a:p>
@@ -14054,7 +14054,7 @@
           <a:p>
             <a:fld id="{5C041930-F8FC-4542-827E-E504F4750562}" type="datetimeFigureOut">
               <a:rPr lang="en-US" smtClean="0"/>
-              <a:t>9/4/2025</a:t>
+              <a:t>9/5/2025</a:t>
             </a:fld>
             <a:endParaRPr lang="en-US"/>
           </a:p>
@@ -14195,7 +14195,7 @@
           <a:p>
             <a:fld id="{5C041930-F8FC-4542-827E-E504F4750562}" type="datetimeFigureOut">
               <a:rPr lang="en-US" smtClean="0"/>
-              <a:t>9/4/2025</a:t>
+              <a:t>9/5/2025</a:t>
             </a:fld>
             <a:endParaRPr lang="en-US"/>
           </a:p>
@@ -14308,7 +14308,7 @@
           <a:p>
             <a:fld id="{5C041930-F8FC-4542-827E-E504F4750562}" type="datetimeFigureOut">
               <a:rPr lang="en-US" smtClean="0"/>
-              <a:t>9/4/2025</a:t>
+              <a:t>9/5/2025</a:t>
             </a:fld>
             <a:endParaRPr lang="en-US"/>
           </a:p>
@@ -14619,7 +14619,7 @@
           <a:p>
             <a:fld id="{5C041930-F8FC-4542-827E-E504F4750562}" type="datetimeFigureOut">
               <a:rPr lang="en-US" smtClean="0"/>
-              <a:t>9/4/2025</a:t>
+              <a:t>9/5/2025</a:t>
             </a:fld>
             <a:endParaRPr lang="en-US"/>
           </a:p>
@@ -14817,7 +14817,7 @@
           <a:p>
             <a:fld id="{16652C1E-0A75-4E3C-905C-182B2377573E}" type="datetimeFigureOut">
               <a:rPr lang="en-US" smtClean="0"/>
-              <a:t>9/4/2025</a:t>
+              <a:t>9/5/2025</a:t>
             </a:fld>
             <a:endParaRPr lang="en-US"/>
           </a:p>
@@ -15105,7 +15105,7 @@
           <a:p>
             <a:fld id="{5C041930-F8FC-4542-827E-E504F4750562}" type="datetimeFigureOut">
               <a:rPr lang="en-US" smtClean="0"/>
-              <a:t>9/4/2025</a:t>
+              <a:t>9/5/2025</a:t>
             </a:fld>
             <a:endParaRPr lang="en-US"/>
           </a:p>
@@ -15303,7 +15303,7 @@
           <a:p>
             <a:fld id="{5C041930-F8FC-4542-827E-E504F4750562}" type="datetimeFigureOut">
               <a:rPr lang="en-US" smtClean="0"/>
-              <a:t>9/4/2025</a:t>
+              <a:t>9/5/2025</a:t>
             </a:fld>
             <a:endParaRPr lang="en-US"/>
           </a:p>
@@ -15511,7 +15511,7 @@
           <a:p>
             <a:fld id="{5C041930-F8FC-4542-827E-E504F4750562}" type="datetimeFigureOut">
               <a:rPr lang="en-US" smtClean="0"/>
-              <a:t>9/4/2025</a:t>
+              <a:t>9/5/2025</a:t>
             </a:fld>
             <a:endParaRPr lang="en-US"/>
           </a:p>
@@ -15786,7 +15786,7 @@
           <a:p>
             <a:fld id="{16652C1E-0A75-4E3C-905C-182B2377573E}" type="datetimeFigureOut">
               <a:rPr lang="en-US" smtClean="0"/>
-              <a:t>9/4/2025</a:t>
+              <a:t>9/5/2025</a:t>
             </a:fld>
             <a:endParaRPr lang="en-US"/>
           </a:p>
@@ -16051,7 +16051,7 @@
           <a:p>
             <a:fld id="{16652C1E-0A75-4E3C-905C-182B2377573E}" type="datetimeFigureOut">
               <a:rPr lang="en-US" smtClean="0"/>
-              <a:t>9/4/2025</a:t>
+              <a:t>9/5/2025</a:t>
             </a:fld>
             <a:endParaRPr lang="en-US"/>
           </a:p>
@@ -16463,7 +16463,7 @@
           <a:p>
             <a:fld id="{16652C1E-0A75-4E3C-905C-182B2377573E}" type="datetimeFigureOut">
               <a:rPr lang="en-US" smtClean="0"/>
-              <a:t>9/4/2025</a:t>
+              <a:t>9/5/2025</a:t>
             </a:fld>
             <a:endParaRPr lang="en-US"/>
           </a:p>
@@ -16604,7 +16604,7 @@
           <a:p>
             <a:fld id="{16652C1E-0A75-4E3C-905C-182B2377573E}" type="datetimeFigureOut">
               <a:rPr lang="en-US" smtClean="0"/>
-              <a:t>9/4/2025</a:t>
+              <a:t>9/5/2025</a:t>
             </a:fld>
             <a:endParaRPr lang="en-US"/>
           </a:p>
@@ -16717,7 +16717,7 @@
           <a:p>
             <a:fld id="{16652C1E-0A75-4E3C-905C-182B2377573E}" type="datetimeFigureOut">
               <a:rPr lang="en-US" smtClean="0"/>
-              <a:t>9/4/2025</a:t>
+              <a:t>9/5/2025</a:t>
             </a:fld>
             <a:endParaRPr lang="en-US"/>
           </a:p>
@@ -17028,7 +17028,7 @@
           <a:p>
             <a:fld id="{16652C1E-0A75-4E3C-905C-182B2377573E}" type="datetimeFigureOut">
               <a:rPr lang="en-US" smtClean="0"/>
-              <a:t>9/4/2025</a:t>
+              <a:t>9/5/2025</a:t>
             </a:fld>
             <a:endParaRPr lang="en-US"/>
           </a:p>
@@ -17316,7 +17316,7 @@
           <a:p>
             <a:fld id="{16652C1E-0A75-4E3C-905C-182B2377573E}" type="datetimeFigureOut">
               <a:rPr lang="en-US" smtClean="0"/>
-              <a:t>9/4/2025</a:t>
+              <a:t>9/5/2025</a:t>
             </a:fld>
             <a:endParaRPr lang="en-US"/>
           </a:p>
@@ -17557,7 +17557,7 @@
           <a:p>
             <a:fld id="{16652C1E-0A75-4E3C-905C-182B2377573E}" type="datetimeFigureOut">
               <a:rPr lang="en-US" smtClean="0"/>
-              <a:t>9/4/2025</a:t>
+              <a:t>9/5/2025</a:t>
             </a:fld>
             <a:endParaRPr lang="en-US"/>
           </a:p>
@@ -18125,7 +18125,7 @@
           <a:p>
             <a:fld id="{5C041930-F8FC-4542-827E-E504F4750562}" type="datetimeFigureOut">
               <a:rPr lang="en-US" smtClean="0"/>
-              <a:t>9/4/2025</a:t>
+              <a:t>9/5/2025</a:t>
             </a:fld>
             <a:endParaRPr lang="en-US"/>
           </a:p>

</xml_diff>